<commit_message>
r1.11: deck Part 2 — pipeline divider + §10 sampling & §11 profiling slides; fix divider title overflow; reframe closing; bump cover rev
</commit_message>
<xml_diff>
--- a/presentations/otel-lgtm-python.pptx
+++ b/presentations/otel-lgtm-python.pptx
@@ -39,9 +39,14 @@
     <p:sldId id="287" r:id="rId33"/>
     <p:sldId id="288" r:id="rId34"/>
     <p:sldId id="289" r:id="rId35"/>
+    <p:sldId id="290" r:id="rId36"/>
+    <p:sldId id="291" r:id="rId37"/>
+    <p:sldId id="292" r:id="rId38"/>
+    <p:sldId id="293" r:id="rId39"/>
+    <p:sldId id="294" r:id="rId40"/>
   </p:sldIdLst>
   <p:notesMasterIdLst>
-    <p:notesMasterId r:id="rId36"/>
+    <p:notesMasterId r:id="rId41"/>
   </p:notesMasterIdLst>
   <p:sldSz cx="12192000" cy="6858000"/>
   <p:notesSz cx="6858000" cy="12192000"/>
@@ -2911,7 +2916,7 @@
           <a:p>
             <a:r>
               <a:rPr lang="en-US" dirty="0"/>
-              <a:t>Re-walk the arc so the audience knows what they hold and what's coming. The foundation gave them the services and the model; this part gave them the three correlated signals, the cost of getting them, and the one-click view that ties them together; the pipeline part is about keeping all of it affordable at volume. Be honest about iteration state: r1.1 is authored against the target versions but not yet run end-to-end here, so it ships marked unverified, and a live rehearsal against the real stack is the next milestone. Point people at the repo: the tutorial mirrors these slides chapter for chapter, and every example has a runnable demo.sh.</a:t>
+              <a:t>The app emits everything; the Collector decides what survives and at what cost. This part keeps telemetry affordable at volume with tail sampling, then adds the fourth signal — profiling — that shows where the time goes inside a slow span.</a:t>
             </a:r>
             <a:endParaRPr lang="en-US" dirty="0"/>
           </a:p>
@@ -2935,6 +2940,446 @@
             <a:fld id="{F7021451-1387-4CA6-816F-3879F97B5CBC}" type="slidenum">
               <a:rPr lang="en-US"/>
               <a:t>34</a:t>
+            </a:fld>
+            <a:endParaRPr lang="en-US"/>
+          </a:p>
+        </p:txBody>
+      </p:sp>
+    </p:spTree>
+    <p:extLst>
+      <p:ext uri="{BB962C8B-B14F-4D97-AF65-F5344CB8AC3E}">
+        <p14:creationId xmlns:p14="http://schemas.microsoft.com/office/powerpoint/2010/main" val="1024086991"/>
+      </p:ext>
+    </p:extLst>
+  </p:cSld>
+  <p:clrMapOvr>
+    <a:masterClrMapping/>
+  </p:clrMapOvr>
+</p:notes>
+</file>
+
+<file path=ppt/notesSlides/notesSlide35.xml><?xml version="1.0" encoding="utf-8"?>
+<p:notes xmlns:a="http://schemas.openxmlformats.org/drawingml/2006/main" xmlns:r="http://schemas.openxmlformats.org/officeDocument/2006/relationships" xmlns:p="http://schemas.openxmlformats.org/presentationml/2006/main">
+  <p:cSld>
+    <p:spTree>
+      <p:nvGrpSpPr>
+        <p:cNvPr id="1" name=""/>
+        <p:cNvGrpSpPr/>
+        <p:nvPr/>
+      </p:nvGrpSpPr>
+      <p:grpSpPr>
+        <a:xfrm>
+          <a:off x="0" y="0"/>
+          <a:ext cx="0" cy="0"/>
+          <a:chOff x="0" y="0"/>
+          <a:chExt cx="0" cy="0"/>
+        </a:xfrm>
+      </p:grpSpPr>
+      <p:sp>
+        <p:nvSpPr>
+          <p:cNvPr id="2" name="Slide Image Placeholder 1"/>
+          <p:cNvSpPr>
+            <a:spLocks noGrp="1" noRot="1" noChangeAspect="1"/>
+          </p:cNvSpPr>
+          <p:nvPr>
+            <p:ph type="sldImg"/>
+          </p:nvPr>
+        </p:nvSpPr>
+        <p:spPr/>
+      </p:sp>
+      <p:sp>
+        <p:nvSpPr>
+          <p:cNvPr id="3" name="Notes Placeholder 2"/>
+          <p:cNvSpPr>
+            <a:spLocks noGrp="1"/>
+          </p:cNvSpPr>
+          <p:nvPr>
+            <p:ph type="body" idx="1"/>
+          </p:nvPr>
+        </p:nvSpPr>
+        <p:spPr/>
+        <p:txBody>
+          <a:bodyPr/>
+          <a:lstStyle/>
+          <a:p>
+            <a:r>
+              <a:rPr lang="en-US" dirty="0"/>
+              <a:t>Set up head-vs-tail visually before the policy slide. The cost of intelligence is memory: tail sampling must hold each in-flight trace until it knows how the trace turned out, then decide.</a:t>
+            </a:r>
+            <a:endParaRPr lang="en-US" dirty="0"/>
+          </a:p>
+        </p:txBody>
+      </p:sp>
+      <p:sp>
+        <p:nvSpPr>
+          <p:cNvPr id="4" name="Slide Number Placeholder 3"/>
+          <p:cNvSpPr>
+            <a:spLocks noGrp="1"/>
+          </p:cNvSpPr>
+          <p:nvPr>
+            <p:ph type="sldNum" sz="quarter" idx="10"/>
+          </p:nvPr>
+        </p:nvSpPr>
+        <p:spPr/>
+        <p:txBody>
+          <a:bodyPr/>
+          <a:lstStyle/>
+          <a:p>
+            <a:fld id="{F7021451-1387-4CA6-816F-3879F97B5CBC}" type="slidenum">
+              <a:rPr lang="en-US"/>
+              <a:t>35</a:t>
+            </a:fld>
+            <a:endParaRPr lang="en-US"/>
+          </a:p>
+        </p:txBody>
+      </p:sp>
+    </p:spTree>
+    <p:extLst>
+      <p:ext uri="{BB962C8B-B14F-4D97-AF65-F5344CB8AC3E}">
+        <p14:creationId xmlns:p14="http://schemas.microsoft.com/office/powerpoint/2010/main" val="1024086991"/>
+      </p:ext>
+    </p:extLst>
+  </p:cSld>
+  <p:clrMapOvr>
+    <a:masterClrMapping/>
+  </p:clrMapOvr>
+</p:notes>
+</file>
+
+<file path=ppt/notesSlides/notesSlide36.xml><?xml version="1.0" encoding="utf-8"?>
+<p:notes xmlns:a="http://schemas.openxmlformats.org/drawingml/2006/main" xmlns:r="http://schemas.openxmlformats.org/officeDocument/2006/relationships" xmlns:p="http://schemas.openxmlformats.org/presentationml/2006/main">
+  <p:cSld>
+    <p:spTree>
+      <p:nvGrpSpPr>
+        <p:cNvPr id="1" name=""/>
+        <p:cNvGrpSpPr/>
+        <p:nvPr/>
+      </p:nvGrpSpPr>
+      <p:grpSpPr>
+        <a:xfrm>
+          <a:off x="0" y="0"/>
+          <a:ext cx="0" cy="0"/>
+          <a:chOff x="0" y="0"/>
+          <a:chExt cx="0" cy="0"/>
+        </a:xfrm>
+      </p:grpSpPr>
+      <p:sp>
+        <p:nvSpPr>
+          <p:cNvPr id="2" name="Slide Image Placeholder 1"/>
+          <p:cNvSpPr>
+            <a:spLocks noGrp="1" noRot="1" noChangeAspect="1"/>
+          </p:cNvSpPr>
+          <p:nvPr>
+            <p:ph type="sldImg"/>
+          </p:nvPr>
+        </p:nvSpPr>
+        <p:spPr/>
+      </p:sp>
+      <p:sp>
+        <p:nvSpPr>
+          <p:cNvPr id="3" name="Notes Placeholder 2"/>
+          <p:cNvSpPr>
+            <a:spLocks noGrp="1"/>
+          </p:cNvSpPr>
+          <p:nvPr>
+            <p:ph type="body" idx="1"/>
+          </p:nvPr>
+        </p:nvSpPr>
+        <p:spPr/>
+        <p:txBody>
+          <a:bodyPr/>
+          <a:lstStyle/>
+          <a:p>
+            <a:r>
+              <a:rPr lang="en-US" dirty="0"/>
+              <a:t>The headline trade: you pay in Collector memory for the ability to keep a trace based on how it turned out. decision_wait holds traces until trailing spans arrive; num_traces caps the buffer so the Collector drops new traces rather than running out of memory. Stress that the app is deliberately not in the sampling business — that separation is why the policy changes without a redeploy.</a:t>
+            </a:r>
+            <a:endParaRPr lang="en-US" dirty="0"/>
+          </a:p>
+        </p:txBody>
+      </p:sp>
+      <p:sp>
+        <p:nvSpPr>
+          <p:cNvPr id="4" name="Slide Number Placeholder 3"/>
+          <p:cNvSpPr>
+            <a:spLocks noGrp="1"/>
+          </p:cNvSpPr>
+          <p:nvPr>
+            <p:ph type="sldNum" sz="quarter" idx="10"/>
+          </p:nvPr>
+        </p:nvSpPr>
+        <p:spPr/>
+        <p:txBody>
+          <a:bodyPr/>
+          <a:lstStyle/>
+          <a:p>
+            <a:fld id="{F7021451-1387-4CA6-816F-3879F97B5CBC}" type="slidenum">
+              <a:rPr lang="en-US"/>
+              <a:t>36</a:t>
+            </a:fld>
+            <a:endParaRPr lang="en-US"/>
+          </a:p>
+        </p:txBody>
+      </p:sp>
+    </p:spTree>
+    <p:extLst>
+      <p:ext uri="{BB962C8B-B14F-4D97-AF65-F5344CB8AC3E}">
+        <p14:creationId xmlns:p14="http://schemas.microsoft.com/office/powerpoint/2010/main" val="1024086991"/>
+      </p:ext>
+    </p:extLst>
+  </p:cSld>
+  <p:clrMapOvr>
+    <a:masterClrMapping/>
+  </p:clrMapOvr>
+</p:notes>
+</file>
+
+<file path=ppt/notesSlides/notesSlide37.xml><?xml version="1.0" encoding="utf-8"?>
+<p:notes xmlns:a="http://schemas.openxmlformats.org/drawingml/2006/main" xmlns:r="http://schemas.openxmlformats.org/officeDocument/2006/relationships" xmlns:p="http://schemas.openxmlformats.org/presentationml/2006/main">
+  <p:cSld>
+    <p:spTree>
+      <p:nvGrpSpPr>
+        <p:cNvPr id="1" name=""/>
+        <p:cNvGrpSpPr/>
+        <p:nvPr/>
+      </p:nvGrpSpPr>
+      <p:grpSpPr>
+        <a:xfrm>
+          <a:off x="0" y="0"/>
+          <a:ext cx="0" cy="0"/>
+          <a:chOff x="0" y="0"/>
+          <a:chExt cx="0" cy="0"/>
+        </a:xfrm>
+      </p:grpSpPr>
+      <p:sp>
+        <p:nvSpPr>
+          <p:cNvPr id="2" name="Slide Image Placeholder 1"/>
+          <p:cNvSpPr>
+            <a:spLocks noGrp="1" noRot="1" noChangeAspect="1"/>
+          </p:cNvSpPr>
+          <p:nvPr>
+            <p:ph type="sldImg"/>
+          </p:nvPr>
+        </p:nvSpPr>
+        <p:spPr/>
+      </p:sp>
+      <p:sp>
+        <p:nvSpPr>
+          <p:cNvPr id="3" name="Notes Placeholder 2"/>
+          <p:cNvSpPr>
+            <a:spLocks noGrp="1"/>
+          </p:cNvSpPr>
+          <p:nvPr>
+            <p:ph type="body" idx="1"/>
+          </p:nvPr>
+        </p:nvSpPr>
+        <p:spPr/>
+        <p:txBody>
+          <a:bodyPr/>
+          <a:lstStyle/>
+          <a:p>
+            <a:r>
+              <a:rPr lang="en-US" dirty="0"/>
+              <a:t>Traces localise the slow span across services; the profile localises what was slow inside one. The link is service + time window, not a shared id — the same correlation pattern as trace→logs, one signal over.</a:t>
+            </a:r>
+            <a:endParaRPr lang="en-US" dirty="0"/>
+          </a:p>
+        </p:txBody>
+      </p:sp>
+      <p:sp>
+        <p:nvSpPr>
+          <p:cNvPr id="4" name="Slide Number Placeholder 3"/>
+          <p:cNvSpPr>
+            <a:spLocks noGrp="1"/>
+          </p:cNvSpPr>
+          <p:nvPr>
+            <p:ph type="sldNum" sz="quarter" idx="10"/>
+          </p:nvPr>
+        </p:nvSpPr>
+        <p:spPr/>
+        <p:txBody>
+          <a:bodyPr/>
+          <a:lstStyle/>
+          <a:p>
+            <a:fld id="{F7021451-1387-4CA6-816F-3879F97B5CBC}" type="slidenum">
+              <a:rPr lang="en-US"/>
+              <a:t>37</a:t>
+            </a:fld>
+            <a:endParaRPr lang="en-US"/>
+          </a:p>
+        </p:txBody>
+      </p:sp>
+    </p:spTree>
+    <p:extLst>
+      <p:ext uri="{BB962C8B-B14F-4D97-AF65-F5344CB8AC3E}">
+        <p14:creationId xmlns:p14="http://schemas.microsoft.com/office/powerpoint/2010/main" val="1024086991"/>
+      </p:ext>
+    </p:extLst>
+  </p:cSld>
+  <p:clrMapOvr>
+    <a:masterClrMapping/>
+  </p:clrMapOvr>
+</p:notes>
+</file>
+
+<file path=ppt/notesSlides/notesSlide38.xml><?xml version="1.0" encoding="utf-8"?>
+<p:notes xmlns:a="http://schemas.openxmlformats.org/drawingml/2006/main" xmlns:r="http://schemas.openxmlformats.org/officeDocument/2006/relationships" xmlns:p="http://schemas.openxmlformats.org/presentationml/2006/main">
+  <p:cSld>
+    <p:spTree>
+      <p:nvGrpSpPr>
+        <p:cNvPr id="1" name=""/>
+        <p:cNvGrpSpPr/>
+        <p:nvPr/>
+      </p:nvGrpSpPr>
+      <p:grpSpPr>
+        <a:xfrm>
+          <a:off x="0" y="0"/>
+          <a:ext cx="0" cy="0"/>
+          <a:chOff x="0" y="0"/>
+          <a:chExt cx="0" cy="0"/>
+        </a:xfrm>
+      </p:grpSpPr>
+      <p:sp>
+        <p:nvSpPr>
+          <p:cNvPr id="2" name="Slide Image Placeholder 1"/>
+          <p:cNvSpPr>
+            <a:spLocks noGrp="1" noRot="1" noChangeAspect="1"/>
+          </p:cNvSpPr>
+          <p:nvPr>
+            <p:ph type="sldImg"/>
+          </p:nvPr>
+        </p:nvSpPr>
+        <p:spPr/>
+      </p:sp>
+      <p:sp>
+        <p:nvSpPr>
+          <p:cNvPr id="3" name="Notes Placeholder 2"/>
+          <p:cNvSpPr>
+            <a:spLocks noGrp="1"/>
+          </p:cNvSpPr>
+          <p:nvPr>
+            <p:ph type="body" idx="1"/>
+          </p:nvPr>
+        </p:nvSpPr>
+        <p:spPr/>
+        <p:txBody>
+          <a:bodyPr/>
+          <a:lstStyle/>
+          <a:p>
+            <a:r>
+              <a:rPr lang="en-US" dirty="0"/>
+              <a:t>Be candid that this chapter is a sketch to validate, not a settled recipe. The good news is the backend ships in the same image; the friction is all on the Python client side and the version-sensitive wiring. obs.profiling is an optional, gated hook that no-ops unless PYROSCOPE_ADDRESS is set.</a:t>
+            </a:r>
+            <a:endParaRPr lang="en-US" dirty="0"/>
+          </a:p>
+        </p:txBody>
+      </p:sp>
+      <p:sp>
+        <p:nvSpPr>
+          <p:cNvPr id="4" name="Slide Number Placeholder 3"/>
+          <p:cNvSpPr>
+            <a:spLocks noGrp="1"/>
+          </p:cNvSpPr>
+          <p:nvPr>
+            <p:ph type="sldNum" sz="quarter" idx="10"/>
+          </p:nvPr>
+        </p:nvSpPr>
+        <p:spPr/>
+        <p:txBody>
+          <a:bodyPr/>
+          <a:lstStyle/>
+          <a:p>
+            <a:fld id="{F7021451-1387-4CA6-816F-3879F97B5CBC}" type="slidenum">
+              <a:rPr lang="en-US"/>
+              <a:t>38</a:t>
+            </a:fld>
+            <a:endParaRPr lang="en-US"/>
+          </a:p>
+        </p:txBody>
+      </p:sp>
+    </p:spTree>
+    <p:extLst>
+      <p:ext uri="{BB962C8B-B14F-4D97-AF65-F5344CB8AC3E}">
+        <p14:creationId xmlns:p14="http://schemas.microsoft.com/office/powerpoint/2010/main" val="1024086991"/>
+      </p:ext>
+    </p:extLst>
+  </p:cSld>
+  <p:clrMapOvr>
+    <a:masterClrMapping/>
+  </p:clrMapOvr>
+</p:notes>
+</file>
+
+<file path=ppt/notesSlides/notesSlide39.xml><?xml version="1.0" encoding="utf-8"?>
+<p:notes xmlns:a="http://schemas.openxmlformats.org/drawingml/2006/main" xmlns:r="http://schemas.openxmlformats.org/officeDocument/2006/relationships" xmlns:p="http://schemas.openxmlformats.org/presentationml/2006/main">
+  <p:cSld>
+    <p:spTree>
+      <p:nvGrpSpPr>
+        <p:cNvPr id="1" name=""/>
+        <p:cNvGrpSpPr/>
+        <p:nvPr/>
+      </p:nvGrpSpPr>
+      <p:grpSpPr>
+        <a:xfrm>
+          <a:off x="0" y="0"/>
+          <a:ext cx="0" cy="0"/>
+          <a:chOff x="0" y="0"/>
+          <a:chExt cx="0" cy="0"/>
+        </a:xfrm>
+      </p:grpSpPr>
+      <p:sp>
+        <p:nvSpPr>
+          <p:cNvPr id="2" name="Slide Image Placeholder 1"/>
+          <p:cNvSpPr>
+            <a:spLocks noGrp="1" noRot="1" noChangeAspect="1"/>
+          </p:cNvSpPr>
+          <p:nvPr>
+            <p:ph type="sldImg"/>
+          </p:nvPr>
+        </p:nvSpPr>
+        <p:spPr/>
+      </p:sp>
+      <p:sp>
+        <p:nvSpPr>
+          <p:cNvPr id="3" name="Notes Placeholder 2"/>
+          <p:cNvSpPr>
+            <a:spLocks noGrp="1"/>
+          </p:cNvSpPr>
+          <p:nvPr>
+            <p:ph type="body" idx="1"/>
+          </p:nvPr>
+        </p:nvSpPr>
+        <p:spPr/>
+        <p:txBody>
+          <a:bodyPr/>
+          <a:lstStyle/>
+          <a:p>
+            <a:r>
+              <a:rPr lang="en-US" dirty="0"/>
+              <a:t>Re-walk the whole arc so the audience knows what they hold. Foundations gave them the services and the model; the three signals gave them the correlated signals, their cost, and the one-click view; the pipeline kept it affordable at volume and added the fourth signal. Be honest about iteration state: this is authored against the target versions but not yet run end-to-end here, so it ships marked unverified, and a live rehearsal is the next milestone. Point people at the repo — the tutorial mirrors these slides chapter for chapter, and every example has a runnable demo.sh.</a:t>
+            </a:r>
+            <a:endParaRPr lang="en-US" dirty="0"/>
+          </a:p>
+        </p:txBody>
+      </p:sp>
+      <p:sp>
+        <p:nvSpPr>
+          <p:cNvPr id="4" name="Slide Number Placeholder 3"/>
+          <p:cNvSpPr>
+            <a:spLocks noGrp="1"/>
+          </p:cNvSpPr>
+          <p:nvPr>
+            <p:ph type="sldNum" sz="quarter" idx="10"/>
+          </p:nvPr>
+        </p:nvSpPr>
+        <p:spPr/>
+        <p:txBody>
+          <a:bodyPr/>
+          <a:lstStyle/>
+          <a:p>
+            <a:fld id="{F7021451-1387-4CA6-816F-3879F97B5CBC}" type="slidenum">
+              <a:rPr lang="en-US"/>
+              <a:t>39</a:t>
             </a:fld>
             <a:endParaRPr lang="en-US"/>
           </a:p>
@@ -4003,7 +4448,7 @@
                 <a:ea typeface="Red Hat Mono" pitchFamily="34" charset="-122"/>
                 <a:cs typeface="Red Hat Mono" pitchFamily="34" charset="-120"/>
               </a:rPr>
-              <a:t>r01.0</a:t>
+              <a:t>r2.0</a:t>
             </a:r>
             <a:endParaRPr lang="en-US" sz="1100" dirty="0"/>
           </a:p>
@@ -7897,7 +8342,7 @@
                 <a:ea typeface="Overpass" pitchFamily="34" charset="-122"/>
                 <a:cs typeface="Overpass" pitchFamily="34" charset="-120"/>
               </a:rPr>
-              <a:t>Traces, metrics, logs — and the thread that ties them</a:t>
+              <a:t>Three signals, one thread</a:t>
             </a:r>
             <a:endParaRPr lang="en-US" sz="4400" dirty="0"/>
           </a:p>
@@ -12028,6 +12473,13 @@
 <file path=ppt/slides/slide34.xml><?xml version="1.0" encoding="utf-8"?>
 <p:sld xmlns:a="http://schemas.openxmlformats.org/drawingml/2006/main" xmlns:r="http://schemas.openxmlformats.org/officeDocument/2006/relationships" xmlns:p="http://schemas.openxmlformats.org/presentationml/2006/main">
   <p:cSld name="Slide 34">
+    <p:bg>
+      <p:bgPr>
+        <a:solidFill>
+          <a:srgbClr val="AB0000"/>
+        </a:solidFill>
+      </p:bgPr>
+    </p:bg>
     <p:spTree>
       <p:nvGrpSpPr>
         <p:cNvPr id="1" name=""/>
@@ -12042,48 +12494,9 @@
           <a:chExt cx="0" cy="0"/>
         </a:xfrm>
       </p:grpSpPr>
-      <p:sp>
-        <p:nvSpPr>
-          <p:cNvPr id="2" name="Text 0"/>
-          <p:cNvSpPr/>
-          <p:nvPr/>
-        </p:nvSpPr>
-        <p:spPr>
-          <a:xfrm>
-            <a:off x="566928" y="6364224"/>
-            <a:ext cx="914400" cy="274320"/>
-          </a:xfrm>
-          <a:prstGeom prst="rect">
-            <a:avLst/>
-          </a:prstGeom>
-          <a:noFill/>
-          <a:ln/>
-        </p:spPr>
-        <p:txBody>
-          <a:bodyPr wrap="square" rtlCol="0" anchor="ctr"/>
-          <a:lstStyle/>
-          <a:p>
-            <a:pPr algn="l" indent="0" marL="0">
-              <a:buNone/>
-            </a:pPr>
-            <a:r>
-              <a:rPr lang="en-US" sz="1000" dirty="0">
-                <a:solidFill>
-                  <a:srgbClr val="8A8A8A"/>
-                </a:solidFill>
-                <a:latin typeface="Red Hat Text" pitchFamily="34" charset="0"/>
-                <a:ea typeface="Red Hat Text" pitchFamily="34" charset="-122"/>
-                <a:cs typeface="Red Hat Text" pitchFamily="34" charset="-120"/>
-              </a:rPr>
-              <a:t>34</a:t>
-            </a:r>
-            <a:endParaRPr lang="en-US" sz="1000" dirty="0"/>
-          </a:p>
-        </p:txBody>
-      </p:sp>
       <p:pic>
         <p:nvPicPr>
-          <p:cNvPr id="3" name="Image 0" descr="./assets/logo-candidate-2.png">    </p:cNvPr>
+          <p:cNvPr id="2" name="Image 0" descr="./assets/section-panel.png">    </p:cNvPr>
           <p:cNvPicPr>
             <a:picLocks noChangeAspect="1"/>
           </p:cNvPicPr>
@@ -12097,8 +12510,8 @@
         </p:blipFill>
         <p:spPr>
           <a:xfrm>
-            <a:off x="10561320" y="6355080"/>
-            <a:ext cx="1033272" cy="246888"/>
+            <a:off x="0" y="0"/>
+            <a:ext cx="12191695" cy="6858000"/>
           </a:xfrm>
           <a:prstGeom prst="rect">
             <a:avLst/>
@@ -12107,14 +12520,14 @@
       </p:pic>
       <p:sp>
         <p:nvSpPr>
-          <p:cNvPr id="4" name="Text 1"/>
+          <p:cNvPr id="3" name="Text 0"/>
           <p:cNvSpPr/>
           <p:nvPr/>
         </p:nvSpPr>
         <p:spPr>
           <a:xfrm>
-            <a:off x="566928" y="384048"/>
-            <a:ext cx="11055096" cy="292608"/>
+            <a:off x="5733288" y="2121408"/>
+            <a:ext cx="5852160" cy="457200"/>
           </a:xfrm>
           <a:prstGeom prst="rect">
             <a:avLst/>
@@ -12130,30 +12543,30 @@
               <a:buNone/>
             </a:pPr>
             <a:r>
-              <a:rPr lang="en-US" sz="1200" b="1" spc="400" kern="0" dirty="0">
-                <a:solidFill>
-                  <a:srgbClr val="EE0000"/>
+              <a:rPr lang="en-US" sz="2200" b="1" spc="600" kern="0" dirty="0">
+                <a:solidFill>
+                  <a:srgbClr val="FFFFFF"/>
                 </a:solidFill>
                 <a:latin typeface="Overpass" pitchFamily="34" charset="0"/>
                 <a:ea typeface="Overpass" pitchFamily="34" charset="-122"/>
                 <a:cs typeface="Overpass" pitchFamily="34" charset="-120"/>
               </a:rPr>
-              <a:t>THE THREE SIGNALS</a:t>
-            </a:r>
-            <a:endParaRPr lang="en-US" sz="1200" dirty="0"/>
-          </a:p>
-        </p:txBody>
-      </p:sp>
-      <p:sp>
-        <p:nvSpPr>
-          <p:cNvPr id="5" name="Text 2"/>
+              <a:t>THE PIPELINE</a:t>
+            </a:r>
+            <a:endParaRPr lang="en-US" sz="2200" dirty="0"/>
+          </a:p>
+        </p:txBody>
+      </p:sp>
+      <p:sp>
+        <p:nvSpPr>
+          <p:cNvPr id="4" name="Text 1"/>
           <p:cNvSpPr/>
           <p:nvPr/>
         </p:nvSpPr>
         <p:spPr>
           <a:xfrm>
-            <a:off x="566928" y="676656"/>
-            <a:ext cx="11055096" cy="1005840"/>
+            <a:off x="5705856" y="2596896"/>
+            <a:ext cx="6126480" cy="1463040"/>
           </a:xfrm>
           <a:prstGeom prst="rect">
             <a:avLst/>
@@ -12169,15 +12582,472 @@
               <a:buNone/>
             </a:pPr>
             <a:r>
-              <a:rPr lang="en-US" sz="3000" b="1" dirty="0">
-                <a:solidFill>
-                  <a:srgbClr val="151515"/>
+              <a:rPr lang="en-US" sz="4400" b="1" dirty="0">
+                <a:solidFill>
+                  <a:srgbClr val="FFFFFF"/>
                 </a:solidFill>
                 <a:latin typeface="Overpass" pitchFamily="34" charset="0"/>
                 <a:ea typeface="Overpass" pitchFamily="34" charset="-122"/>
                 <a:cs typeface="Overpass" pitchFamily="34" charset="-120"/>
               </a:rPr>
-              <a:t>Where this goes next</a:t>
+              <a:t>Decide in the Collector</a:t>
+            </a:r>
+            <a:endParaRPr lang="en-US" sz="4400" dirty="0"/>
+          </a:p>
+        </p:txBody>
+      </p:sp>
+      <p:sp>
+        <p:nvSpPr>
+          <p:cNvPr id="5" name="Text 2"/>
+          <p:cNvSpPr/>
+          <p:nvPr/>
+        </p:nvSpPr>
+        <p:spPr>
+          <a:xfrm>
+            <a:off x="5733288" y="4160520"/>
+            <a:ext cx="6035040" cy="731520"/>
+          </a:xfrm>
+          <a:prstGeom prst="rect">
+            <a:avLst/>
+          </a:prstGeom>
+          <a:noFill/>
+          <a:ln/>
+        </p:spPr>
+        <p:txBody>
+          <a:bodyPr wrap="square" rtlCol="0" anchor="t"/>
+          <a:lstStyle/>
+          <a:p>
+            <a:pPr algn="l" indent="0" marL="0">
+              <a:buNone/>
+            </a:pPr>
+            <a:r>
+              <a:rPr lang="en-US" sz="1600" i="1" dirty="0">
+                <a:solidFill>
+                  <a:srgbClr val="FFD9D9"/>
+                </a:solidFill>
+                <a:latin typeface="Red Hat Text" pitchFamily="34" charset="0"/>
+                <a:ea typeface="Red Hat Text" pitchFamily="34" charset="-122"/>
+                <a:cs typeface="Red Hat Text" pitchFamily="34" charset="-120"/>
+              </a:rPr>
+              <a:t>Sampling · Continuous profiling</a:t>
+            </a:r>
+            <a:endParaRPr lang="en-US" sz="1600" dirty="0"/>
+          </a:p>
+        </p:txBody>
+      </p:sp>
+      <p:pic>
+        <p:nvPicPr>
+          <p:cNvPr id="6" name="Image 1" descr="./assets/redhat-logo-white.png">    </p:cNvPr>
+          <p:cNvPicPr>
+            <a:picLocks noChangeAspect="1"/>
+          </p:cNvPicPr>
+          <p:nvPr/>
+        </p:nvPicPr>
+        <p:blipFill>
+          <a:blip r:embed="rId2"/>
+          <a:stretch>
+            <a:fillRect/>
+          </a:stretch>
+        </p:blipFill>
+        <p:spPr>
+          <a:xfrm>
+            <a:off x="10442448" y="6291072"/>
+            <a:ext cx="1216152" cy="283464"/>
+          </a:xfrm>
+          <a:prstGeom prst="rect">
+            <a:avLst/>
+          </a:prstGeom>
+        </p:spPr>
+      </p:pic>
+    </p:spTree>
+  </p:cSld>
+  <p:clrMapOvr>
+    <a:masterClrMapping/>
+  </p:clrMapOvr>
+</p:sld>
+</file>
+
+<file path=ppt/slides/slide35.xml><?xml version="1.0" encoding="utf-8"?>
+<p:sld xmlns:a="http://schemas.openxmlformats.org/drawingml/2006/main" xmlns:r="http://schemas.openxmlformats.org/officeDocument/2006/relationships" xmlns:p="http://schemas.openxmlformats.org/presentationml/2006/main">
+  <p:cSld name="Slide 35">
+    <p:spTree>
+      <p:nvGrpSpPr>
+        <p:cNvPr id="1" name=""/>
+        <p:cNvGrpSpPr/>
+        <p:nvPr/>
+      </p:nvGrpSpPr>
+      <p:grpSpPr>
+        <a:xfrm>
+          <a:off x="0" y="0"/>
+          <a:ext cx="0" cy="0"/>
+          <a:chOff x="0" y="0"/>
+          <a:chExt cx="0" cy="0"/>
+        </a:xfrm>
+      </p:grpSpPr>
+      <p:sp>
+        <p:nvSpPr>
+          <p:cNvPr id="2" name="Text 0"/>
+          <p:cNvSpPr/>
+          <p:nvPr/>
+        </p:nvSpPr>
+        <p:spPr>
+          <a:xfrm>
+            <a:off x="566928" y="6364224"/>
+            <a:ext cx="914400" cy="274320"/>
+          </a:xfrm>
+          <a:prstGeom prst="rect">
+            <a:avLst/>
+          </a:prstGeom>
+          <a:noFill/>
+          <a:ln/>
+        </p:spPr>
+        <p:txBody>
+          <a:bodyPr wrap="square" rtlCol="0" anchor="ctr"/>
+          <a:lstStyle/>
+          <a:p>
+            <a:pPr algn="l" indent="0" marL="0">
+              <a:buNone/>
+            </a:pPr>
+            <a:r>
+              <a:rPr lang="en-US" sz="1000" dirty="0">
+                <a:solidFill>
+                  <a:srgbClr val="8A8A8A"/>
+                </a:solidFill>
+                <a:latin typeface="Red Hat Text" pitchFamily="34" charset="0"/>
+                <a:ea typeface="Red Hat Text" pitchFamily="34" charset="-122"/>
+                <a:cs typeface="Red Hat Text" pitchFamily="34" charset="-120"/>
+              </a:rPr>
+              <a:t>35</a:t>
+            </a:r>
+            <a:endParaRPr lang="en-US" sz="1000" dirty="0"/>
+          </a:p>
+        </p:txBody>
+      </p:sp>
+      <p:pic>
+        <p:nvPicPr>
+          <p:cNvPr id="3" name="Image 0" descr="./assets/logo-candidate-2.png">    </p:cNvPr>
+          <p:cNvPicPr>
+            <a:picLocks noChangeAspect="1"/>
+          </p:cNvPicPr>
+          <p:nvPr/>
+        </p:nvPicPr>
+        <p:blipFill>
+          <a:blip r:embed="rId1"/>
+          <a:stretch>
+            <a:fillRect/>
+          </a:stretch>
+        </p:blipFill>
+        <p:spPr>
+          <a:xfrm>
+            <a:off x="10561320" y="6355080"/>
+            <a:ext cx="1033272" cy="246888"/>
+          </a:xfrm>
+          <a:prstGeom prst="rect">
+            <a:avLst/>
+          </a:prstGeom>
+        </p:spPr>
+      </p:pic>
+      <p:sp>
+        <p:nvSpPr>
+          <p:cNvPr id="4" name="Text 1"/>
+          <p:cNvSpPr/>
+          <p:nvPr/>
+        </p:nvSpPr>
+        <p:spPr>
+          <a:xfrm>
+            <a:off x="566928" y="384048"/>
+            <a:ext cx="11055096" cy="292608"/>
+          </a:xfrm>
+          <a:prstGeom prst="rect">
+            <a:avLst/>
+          </a:prstGeom>
+          <a:noFill/>
+          <a:ln/>
+        </p:spPr>
+        <p:txBody>
+          <a:bodyPr wrap="square" rtlCol="0" anchor="ctr"/>
+          <a:lstStyle/>
+          <a:p>
+            <a:pPr algn="l" indent="0" marL="0">
+              <a:buNone/>
+            </a:pPr>
+            <a:r>
+              <a:rPr lang="en-US" sz="1200" b="1" spc="400" kern="0" dirty="0">
+                <a:solidFill>
+                  <a:srgbClr val="EE0000"/>
+                </a:solidFill>
+                <a:latin typeface="Overpass" pitchFamily="34" charset="0"/>
+                <a:ea typeface="Overpass" pitchFamily="34" charset="-122"/>
+                <a:cs typeface="Overpass" pitchFamily="34" charset="-120"/>
+              </a:rPr>
+              <a:t>THE PIPELINE · SAMPLING</a:t>
+            </a:r>
+            <a:endParaRPr lang="en-US" sz="1200" dirty="0"/>
+          </a:p>
+        </p:txBody>
+      </p:sp>
+      <p:sp>
+        <p:nvSpPr>
+          <p:cNvPr id="5" name="Text 2"/>
+          <p:cNvSpPr/>
+          <p:nvPr/>
+        </p:nvSpPr>
+        <p:spPr>
+          <a:xfrm>
+            <a:off x="566928" y="676656"/>
+            <a:ext cx="11055096" cy="1005840"/>
+          </a:xfrm>
+          <a:prstGeom prst="rect">
+            <a:avLst/>
+          </a:prstGeom>
+          <a:noFill/>
+          <a:ln/>
+        </p:spPr>
+        <p:txBody>
+          <a:bodyPr wrap="square" rtlCol="0" anchor="t"/>
+          <a:lstStyle/>
+          <a:p>
+            <a:pPr algn="l" indent="0" marL="0">
+              <a:buNone/>
+            </a:pPr>
+            <a:r>
+              <a:rPr lang="en-US" sz="3000" b="1" dirty="0">
+                <a:solidFill>
+                  <a:srgbClr val="151515"/>
+                </a:solidFill>
+                <a:latin typeface="Overpass" pitchFamily="34" charset="0"/>
+                <a:ea typeface="Overpass" pitchFamily="34" charset="-122"/>
+                <a:cs typeface="Overpass" pitchFamily="34" charset="-120"/>
+              </a:rPr>
+              <a:t>Where you decide what to keep</a:t>
+            </a:r>
+            <a:endParaRPr lang="en-US" sz="3000" dirty="0"/>
+          </a:p>
+        </p:txBody>
+      </p:sp>
+      <p:pic>
+        <p:nvPicPr>
+          <p:cNvPr id="6" name="Image 1" descr="./png/fig-09-sampling-location.png">    </p:cNvPr>
+          <p:cNvPicPr>
+            <a:picLocks noChangeAspect="1"/>
+          </p:cNvPicPr>
+          <p:nvPr/>
+        </p:nvPicPr>
+        <p:blipFill>
+          <a:blip r:embed="rId2"/>
+          <a:srcRect l="0" r="0" t="0" b="0"/>
+          <a:stretch/>
+        </p:blipFill>
+        <p:spPr>
+          <a:xfrm>
+            <a:off x="1645920" y="1600200"/>
+            <a:ext cx="8906256" cy="4343400"/>
+          </a:xfrm>
+          <a:prstGeom prst="rect">
+            <a:avLst/>
+          </a:prstGeom>
+        </p:spPr>
+      </p:pic>
+      <p:sp>
+        <p:nvSpPr>
+          <p:cNvPr id="7" name="Text 3"/>
+          <p:cNvSpPr/>
+          <p:nvPr/>
+        </p:nvSpPr>
+        <p:spPr>
+          <a:xfrm>
+            <a:off x="566928" y="5943600"/>
+            <a:ext cx="11055096" cy="310896"/>
+          </a:xfrm>
+          <a:prstGeom prst="rect">
+            <a:avLst/>
+          </a:prstGeom>
+          <a:noFill/>
+          <a:ln/>
+        </p:spPr>
+        <p:txBody>
+          <a:bodyPr wrap="square" rtlCol="0" anchor="ctr"/>
+          <a:lstStyle/>
+          <a:p>
+            <a:pPr algn="ctr" indent="0" marL="0">
+              <a:buNone/>
+            </a:pPr>
+            <a:r>
+              <a:rPr lang="en-US" sz="1300" i="1" dirty="0">
+                <a:solidFill>
+                  <a:srgbClr val="5A5A5A"/>
+                </a:solidFill>
+                <a:latin typeface="Red Hat Text" pitchFamily="34" charset="0"/>
+                <a:ea typeface="Red Hat Text" pitchFamily="34" charset="-122"/>
+                <a:cs typeface="Red Hat Text" pitchFamily="34" charset="-120"/>
+              </a:rPr>
+              <a:t>Figure 10.1 — Head sampling decides at the SDK, cheap and blind; tail sampling buffers the whole trace in the Collector, then keeps errors, slow, and critical routes.</a:t>
+            </a:r>
+            <a:endParaRPr lang="en-US" sz="1300" dirty="0"/>
+          </a:p>
+        </p:txBody>
+      </p:sp>
+    </p:spTree>
+  </p:cSld>
+  <p:clrMapOvr>
+    <a:masterClrMapping/>
+  </p:clrMapOvr>
+</p:sld>
+</file>
+
+<file path=ppt/slides/slide36.xml><?xml version="1.0" encoding="utf-8"?>
+<p:sld xmlns:a="http://schemas.openxmlformats.org/drawingml/2006/main" xmlns:r="http://schemas.openxmlformats.org/officeDocument/2006/relationships" xmlns:p="http://schemas.openxmlformats.org/presentationml/2006/main">
+  <p:cSld name="Slide 36">
+    <p:spTree>
+      <p:nvGrpSpPr>
+        <p:cNvPr id="1" name=""/>
+        <p:cNvGrpSpPr/>
+        <p:nvPr/>
+      </p:nvGrpSpPr>
+      <p:grpSpPr>
+        <a:xfrm>
+          <a:off x="0" y="0"/>
+          <a:ext cx="0" cy="0"/>
+          <a:chOff x="0" y="0"/>
+          <a:chExt cx="0" cy="0"/>
+        </a:xfrm>
+      </p:grpSpPr>
+      <p:sp>
+        <p:nvSpPr>
+          <p:cNvPr id="2" name="Text 0"/>
+          <p:cNvSpPr/>
+          <p:nvPr/>
+        </p:nvSpPr>
+        <p:spPr>
+          <a:xfrm>
+            <a:off x="566928" y="6364224"/>
+            <a:ext cx="914400" cy="274320"/>
+          </a:xfrm>
+          <a:prstGeom prst="rect">
+            <a:avLst/>
+          </a:prstGeom>
+          <a:noFill/>
+          <a:ln/>
+        </p:spPr>
+        <p:txBody>
+          <a:bodyPr wrap="square" rtlCol="0" anchor="ctr"/>
+          <a:lstStyle/>
+          <a:p>
+            <a:pPr algn="l" indent="0" marL="0">
+              <a:buNone/>
+            </a:pPr>
+            <a:r>
+              <a:rPr lang="en-US" sz="1000" dirty="0">
+                <a:solidFill>
+                  <a:srgbClr val="8A8A8A"/>
+                </a:solidFill>
+                <a:latin typeface="Red Hat Text" pitchFamily="34" charset="0"/>
+                <a:ea typeface="Red Hat Text" pitchFamily="34" charset="-122"/>
+                <a:cs typeface="Red Hat Text" pitchFamily="34" charset="-120"/>
+              </a:rPr>
+              <a:t>36</a:t>
+            </a:r>
+            <a:endParaRPr lang="en-US" sz="1000" dirty="0"/>
+          </a:p>
+        </p:txBody>
+      </p:sp>
+      <p:pic>
+        <p:nvPicPr>
+          <p:cNvPr id="3" name="Image 0" descr="./assets/logo-candidate-2.png">    </p:cNvPr>
+          <p:cNvPicPr>
+            <a:picLocks noChangeAspect="1"/>
+          </p:cNvPicPr>
+          <p:nvPr/>
+        </p:nvPicPr>
+        <p:blipFill>
+          <a:blip r:embed="rId1"/>
+          <a:stretch>
+            <a:fillRect/>
+          </a:stretch>
+        </p:blipFill>
+        <p:spPr>
+          <a:xfrm>
+            <a:off x="10561320" y="6355080"/>
+            <a:ext cx="1033272" cy="246888"/>
+          </a:xfrm>
+          <a:prstGeom prst="rect">
+            <a:avLst/>
+          </a:prstGeom>
+        </p:spPr>
+      </p:pic>
+      <p:sp>
+        <p:nvSpPr>
+          <p:cNvPr id="4" name="Text 1"/>
+          <p:cNvSpPr/>
+          <p:nvPr/>
+        </p:nvSpPr>
+        <p:spPr>
+          <a:xfrm>
+            <a:off x="566928" y="384048"/>
+            <a:ext cx="11055096" cy="292608"/>
+          </a:xfrm>
+          <a:prstGeom prst="rect">
+            <a:avLst/>
+          </a:prstGeom>
+          <a:noFill/>
+          <a:ln/>
+        </p:spPr>
+        <p:txBody>
+          <a:bodyPr wrap="square" rtlCol="0" anchor="ctr"/>
+          <a:lstStyle/>
+          <a:p>
+            <a:pPr algn="l" indent="0" marL="0">
+              <a:buNone/>
+            </a:pPr>
+            <a:r>
+              <a:rPr lang="en-US" sz="1200" b="1" spc="400" kern="0" dirty="0">
+                <a:solidFill>
+                  <a:srgbClr val="EE0000"/>
+                </a:solidFill>
+                <a:latin typeface="Overpass" pitchFamily="34" charset="0"/>
+                <a:ea typeface="Overpass" pitchFamily="34" charset="-122"/>
+                <a:cs typeface="Overpass" pitchFamily="34" charset="-120"/>
+              </a:rPr>
+              <a:t>THE PIPELINE · SAMPLING</a:t>
+            </a:r>
+            <a:endParaRPr lang="en-US" sz="1200" dirty="0"/>
+          </a:p>
+        </p:txBody>
+      </p:sp>
+      <p:sp>
+        <p:nvSpPr>
+          <p:cNvPr id="5" name="Text 2"/>
+          <p:cNvSpPr/>
+          <p:nvPr/>
+        </p:nvSpPr>
+        <p:spPr>
+          <a:xfrm>
+            <a:off x="566928" y="676656"/>
+            <a:ext cx="11055096" cy="1005840"/>
+          </a:xfrm>
+          <a:prstGeom prst="rect">
+            <a:avLst/>
+          </a:prstGeom>
+          <a:noFill/>
+          <a:ln/>
+        </p:spPr>
+        <p:txBody>
+          <a:bodyPr wrap="square" rtlCol="0" anchor="t"/>
+          <a:lstStyle/>
+          <a:p>
+            <a:pPr algn="l" indent="0" marL="0">
+              <a:buNone/>
+            </a:pPr>
+            <a:r>
+              <a:rPr lang="en-US" sz="3000" b="1" dirty="0">
+                <a:solidFill>
+                  <a:srgbClr val="151515"/>
+                </a:solidFill>
+                <a:latin typeface="Overpass" pitchFamily="34" charset="0"/>
+                <a:ea typeface="Overpass" pitchFamily="34" charset="-122"/>
+                <a:cs typeface="Overpass" pitchFamily="34" charset="-120"/>
+              </a:rPr>
+              <a:t>Keep errors, slow, and critical — sample the rest</a:t>
             </a:r>
             <a:endParaRPr lang="en-US" sz="3000" dirty="0"/>
           </a:p>
@@ -12223,7 +13093,7 @@
                 <a:ea typeface="Red Hat Text" pitchFamily="34" charset="-122"/>
                 <a:cs typeface="Red Hat Text" pitchFamily="34" charset="-120"/>
               </a:rPr>
-              <a:t>You now have the full correlation story across the services: traces across REST and gRPC for free, metrics with exemplars, logs stamped with the trace_id, custom spans that carry the trace across Kafka, the honest auto/custom/hybrid trade-off, and a Grafana walkthrough that pivots trace → logs → metrics on one click.</a:t>
+              <a:t>Head sampling decides in the SDK before the request runs: cheap, but blind — a 5% head sampler keeps 5% of your errors too. Tail sampling decides in the Collector once the trace is complete, so it can keep a trace because it errored, was slow, or hit a route you care about.</a:t>
             </a:r>
             <a:endParaRPr lang="en-US" sz="1500" dirty="0"/>
           </a:p>
@@ -12247,7 +13117,7 @@
                 <a:ea typeface="Red Hat Text" pitchFamily="34" charset="-122"/>
                 <a:cs typeface="Red Hat Text" pitchFamily="34" charset="-120"/>
               </a:rPr>
-              <a:t>Next part — the pipeline: move the costly decisions into the Collector. Where sampling happens, what it costs to keep telemetry at volume, and continuous profiling.</a:t>
+              <a:t>The policy is OR-evaluated in stack/otelcol/config.tail-sampling.yaml: keep every ERROR, every request over 1s, every /orders, plus a 5% probabilistic baseline of the healthy rest.</a:t>
             </a:r>
             <a:endParaRPr lang="en-US" sz="1500" dirty="0"/>
           </a:p>
@@ -12271,7 +13141,755 @@
                 <a:ea typeface="Red Hat Text" pitchFamily="34" charset="-122"/>
                 <a:cs typeface="Red Hat Text" pitchFamily="34" charset="-120"/>
               </a:rPr>
-              <a:t>Iteration r1.1 ships Sections 0–9, the six example services, the shared protos and obs library, and Demos 1–7. The Collector-side pipeline demos land in r2.0; see the iteration plan in the repo.</a:t>
+              <a:t>The services export 100% and own no sampling — what you keep is a Collector config change, not a redeploy. The cost is Collector RAM: roughly 10–50 KB per in-flight trace held for the decision window (here 30s), capped by num_traces.</a:t>
+            </a:r>
+            <a:endParaRPr lang="en-US" sz="1500" dirty="0"/>
+          </a:p>
+        </p:txBody>
+      </p:sp>
+    </p:spTree>
+  </p:cSld>
+  <p:clrMapOvr>
+    <a:masterClrMapping/>
+  </p:clrMapOvr>
+</p:sld>
+</file>
+
+<file path=ppt/slides/slide37.xml><?xml version="1.0" encoding="utf-8"?>
+<p:sld xmlns:a="http://schemas.openxmlformats.org/drawingml/2006/main" xmlns:r="http://schemas.openxmlformats.org/officeDocument/2006/relationships" xmlns:p="http://schemas.openxmlformats.org/presentationml/2006/main">
+  <p:cSld name="Slide 37">
+    <p:spTree>
+      <p:nvGrpSpPr>
+        <p:cNvPr id="1" name=""/>
+        <p:cNvGrpSpPr/>
+        <p:nvPr/>
+      </p:nvGrpSpPr>
+      <p:grpSpPr>
+        <a:xfrm>
+          <a:off x="0" y="0"/>
+          <a:ext cx="0" cy="0"/>
+          <a:chOff x="0" y="0"/>
+          <a:chExt cx="0" cy="0"/>
+        </a:xfrm>
+      </p:grpSpPr>
+      <p:sp>
+        <p:nvSpPr>
+          <p:cNvPr id="2" name="Text 0"/>
+          <p:cNvSpPr/>
+          <p:nvPr/>
+        </p:nvSpPr>
+        <p:spPr>
+          <a:xfrm>
+            <a:off x="566928" y="6364224"/>
+            <a:ext cx="914400" cy="274320"/>
+          </a:xfrm>
+          <a:prstGeom prst="rect">
+            <a:avLst/>
+          </a:prstGeom>
+          <a:noFill/>
+          <a:ln/>
+        </p:spPr>
+        <p:txBody>
+          <a:bodyPr wrap="square" rtlCol="0" anchor="ctr"/>
+          <a:lstStyle/>
+          <a:p>
+            <a:pPr algn="l" indent="0" marL="0">
+              <a:buNone/>
+            </a:pPr>
+            <a:r>
+              <a:rPr lang="en-US" sz="1000" dirty="0">
+                <a:solidFill>
+                  <a:srgbClr val="8A8A8A"/>
+                </a:solidFill>
+                <a:latin typeface="Red Hat Text" pitchFamily="34" charset="0"/>
+                <a:ea typeface="Red Hat Text" pitchFamily="34" charset="-122"/>
+                <a:cs typeface="Red Hat Text" pitchFamily="34" charset="-120"/>
+              </a:rPr>
+              <a:t>37</a:t>
+            </a:r>
+            <a:endParaRPr lang="en-US" sz="1000" dirty="0"/>
+          </a:p>
+        </p:txBody>
+      </p:sp>
+      <p:pic>
+        <p:nvPicPr>
+          <p:cNvPr id="3" name="Image 0" descr="./assets/logo-candidate-2.png">    </p:cNvPr>
+          <p:cNvPicPr>
+            <a:picLocks noChangeAspect="1"/>
+          </p:cNvPicPr>
+          <p:nvPr/>
+        </p:nvPicPr>
+        <p:blipFill>
+          <a:blip r:embed="rId1"/>
+          <a:stretch>
+            <a:fillRect/>
+          </a:stretch>
+        </p:blipFill>
+        <p:spPr>
+          <a:xfrm>
+            <a:off x="10561320" y="6355080"/>
+            <a:ext cx="1033272" cy="246888"/>
+          </a:xfrm>
+          <a:prstGeom prst="rect">
+            <a:avLst/>
+          </a:prstGeom>
+        </p:spPr>
+      </p:pic>
+      <p:sp>
+        <p:nvSpPr>
+          <p:cNvPr id="4" name="Text 1"/>
+          <p:cNvSpPr/>
+          <p:nvPr/>
+        </p:nvSpPr>
+        <p:spPr>
+          <a:xfrm>
+            <a:off x="566928" y="384048"/>
+            <a:ext cx="11055096" cy="292608"/>
+          </a:xfrm>
+          <a:prstGeom prst="rect">
+            <a:avLst/>
+          </a:prstGeom>
+          <a:noFill/>
+          <a:ln/>
+        </p:spPr>
+        <p:txBody>
+          <a:bodyPr wrap="square" rtlCol="0" anchor="ctr"/>
+          <a:lstStyle/>
+          <a:p>
+            <a:pPr algn="l" indent="0" marL="0">
+              <a:buNone/>
+            </a:pPr>
+            <a:r>
+              <a:rPr lang="en-US" sz="1200" b="1" spc="400" kern="0" dirty="0">
+                <a:solidFill>
+                  <a:srgbClr val="EE0000"/>
+                </a:solidFill>
+                <a:latin typeface="Overpass" pitchFamily="34" charset="0"/>
+                <a:ea typeface="Overpass" pitchFamily="34" charset="-122"/>
+                <a:cs typeface="Overpass" pitchFamily="34" charset="-120"/>
+              </a:rPr>
+              <a:t>THE PIPELINE · PROFILING</a:t>
+            </a:r>
+            <a:endParaRPr lang="en-US" sz="1200" dirty="0"/>
+          </a:p>
+        </p:txBody>
+      </p:sp>
+      <p:sp>
+        <p:nvSpPr>
+          <p:cNvPr id="5" name="Text 2"/>
+          <p:cNvSpPr/>
+          <p:nvPr/>
+        </p:nvSpPr>
+        <p:spPr>
+          <a:xfrm>
+            <a:off x="566928" y="676656"/>
+            <a:ext cx="11055096" cy="1005840"/>
+          </a:xfrm>
+          <a:prstGeom prst="rect">
+            <a:avLst/>
+          </a:prstGeom>
+          <a:noFill/>
+          <a:ln/>
+        </p:spPr>
+        <p:txBody>
+          <a:bodyPr wrap="square" rtlCol="0" anchor="t"/>
+          <a:lstStyle/>
+          <a:p>
+            <a:pPr algn="l" indent="0" marL="0">
+              <a:buNone/>
+            </a:pPr>
+            <a:r>
+              <a:rPr lang="en-US" sz="3000" b="1" dirty="0">
+                <a:solidFill>
+                  <a:srgbClr val="151515"/>
+                </a:solidFill>
+                <a:latin typeface="Overpass" pitchFamily="34" charset="0"/>
+                <a:ea typeface="Overpass" pitchFamily="34" charset="-122"/>
+                <a:cs typeface="Overpass" pitchFamily="34" charset="-120"/>
+              </a:rPr>
+              <a:t>The fourth signal: inside the slow span</a:t>
+            </a:r>
+            <a:endParaRPr lang="en-US" sz="3000" dirty="0"/>
+          </a:p>
+        </p:txBody>
+      </p:sp>
+      <p:pic>
+        <p:nvPicPr>
+          <p:cNvPr id="6" name="Image 1" descr="./png/fig-12-profiling.png">    </p:cNvPr>
+          <p:cNvPicPr>
+            <a:picLocks noChangeAspect="1"/>
+          </p:cNvPicPr>
+          <p:nvPr/>
+        </p:nvPicPr>
+        <p:blipFill>
+          <a:blip r:embed="rId2"/>
+          <a:srcRect l="0" r="0" t="0" b="0"/>
+          <a:stretch/>
+        </p:blipFill>
+        <p:spPr>
+          <a:xfrm>
+            <a:off x="1645920" y="1600200"/>
+            <a:ext cx="8906256" cy="4343400"/>
+          </a:xfrm>
+          <a:prstGeom prst="rect">
+            <a:avLst/>
+          </a:prstGeom>
+        </p:spPr>
+      </p:pic>
+      <p:sp>
+        <p:nvSpPr>
+          <p:cNvPr id="7" name="Text 3"/>
+          <p:cNvSpPr/>
+          <p:nvPr/>
+        </p:nvSpPr>
+        <p:spPr>
+          <a:xfrm>
+            <a:off x="566928" y="5943600"/>
+            <a:ext cx="11055096" cy="310896"/>
+          </a:xfrm>
+          <a:prstGeom prst="rect">
+            <a:avLst/>
+          </a:prstGeom>
+          <a:noFill/>
+          <a:ln/>
+        </p:spPr>
+        <p:txBody>
+          <a:bodyPr wrap="square" rtlCol="0" anchor="ctr"/>
+          <a:lstStyle/>
+          <a:p>
+            <a:pPr algn="ctr" indent="0" marL="0">
+              <a:buNone/>
+            </a:pPr>
+            <a:r>
+              <a:rPr lang="en-US" sz="1300" i="1" dirty="0">
+                <a:solidFill>
+                  <a:srgbClr val="5A5A5A"/>
+                </a:solidFill>
+                <a:latin typeface="Red Hat Text" pitchFamily="34" charset="0"/>
+                <a:ea typeface="Red Hat Text" pitchFamily="34" charset="-122"/>
+                <a:cs typeface="Red Hat Text" pitchFamily="34" charset="-120"/>
+              </a:rPr>
+              <a:t>Figure 11.1 — A slow span in Tempo links by service + time window to a CPU flame graph in Pyroscope, showing which functions inside it spent the time.</a:t>
+            </a:r>
+            <a:endParaRPr lang="en-US" sz="1300" dirty="0"/>
+          </a:p>
+        </p:txBody>
+      </p:sp>
+    </p:spTree>
+  </p:cSld>
+  <p:clrMapOvr>
+    <a:masterClrMapping/>
+  </p:clrMapOvr>
+</p:sld>
+</file>
+
+<file path=ppt/slides/slide38.xml><?xml version="1.0" encoding="utf-8"?>
+<p:sld xmlns:a="http://schemas.openxmlformats.org/drawingml/2006/main" xmlns:r="http://schemas.openxmlformats.org/officeDocument/2006/relationships" xmlns:p="http://schemas.openxmlformats.org/presentationml/2006/main">
+  <p:cSld name="Slide 38">
+    <p:spTree>
+      <p:nvGrpSpPr>
+        <p:cNvPr id="1" name=""/>
+        <p:cNvGrpSpPr/>
+        <p:nvPr/>
+      </p:nvGrpSpPr>
+      <p:grpSpPr>
+        <a:xfrm>
+          <a:off x="0" y="0"/>
+          <a:ext cx="0" cy="0"/>
+          <a:chOff x="0" y="0"/>
+          <a:chExt cx="0" cy="0"/>
+        </a:xfrm>
+      </p:grpSpPr>
+      <p:sp>
+        <p:nvSpPr>
+          <p:cNvPr id="2" name="Text 0"/>
+          <p:cNvSpPr/>
+          <p:nvPr/>
+        </p:nvSpPr>
+        <p:spPr>
+          <a:xfrm>
+            <a:off x="566928" y="6364224"/>
+            <a:ext cx="914400" cy="274320"/>
+          </a:xfrm>
+          <a:prstGeom prst="rect">
+            <a:avLst/>
+          </a:prstGeom>
+          <a:noFill/>
+          <a:ln/>
+        </p:spPr>
+        <p:txBody>
+          <a:bodyPr wrap="square" rtlCol="0" anchor="ctr"/>
+          <a:lstStyle/>
+          <a:p>
+            <a:pPr algn="l" indent="0" marL="0">
+              <a:buNone/>
+            </a:pPr>
+            <a:r>
+              <a:rPr lang="en-US" sz="1000" dirty="0">
+                <a:solidFill>
+                  <a:srgbClr val="8A8A8A"/>
+                </a:solidFill>
+                <a:latin typeface="Red Hat Text" pitchFamily="34" charset="0"/>
+                <a:ea typeface="Red Hat Text" pitchFamily="34" charset="-122"/>
+                <a:cs typeface="Red Hat Text" pitchFamily="34" charset="-120"/>
+              </a:rPr>
+              <a:t>38</a:t>
+            </a:r>
+            <a:endParaRPr lang="en-US" sz="1000" dirty="0"/>
+          </a:p>
+        </p:txBody>
+      </p:sp>
+      <p:pic>
+        <p:nvPicPr>
+          <p:cNvPr id="3" name="Image 0" descr="./assets/logo-candidate-2.png">    </p:cNvPr>
+          <p:cNvPicPr>
+            <a:picLocks noChangeAspect="1"/>
+          </p:cNvPicPr>
+          <p:nvPr/>
+        </p:nvPicPr>
+        <p:blipFill>
+          <a:blip r:embed="rId1"/>
+          <a:stretch>
+            <a:fillRect/>
+          </a:stretch>
+        </p:blipFill>
+        <p:spPr>
+          <a:xfrm>
+            <a:off x="10561320" y="6355080"/>
+            <a:ext cx="1033272" cy="246888"/>
+          </a:xfrm>
+          <a:prstGeom prst="rect">
+            <a:avLst/>
+          </a:prstGeom>
+        </p:spPr>
+      </p:pic>
+      <p:sp>
+        <p:nvSpPr>
+          <p:cNvPr id="4" name="Text 1"/>
+          <p:cNvSpPr/>
+          <p:nvPr/>
+        </p:nvSpPr>
+        <p:spPr>
+          <a:xfrm>
+            <a:off x="566928" y="384048"/>
+            <a:ext cx="11055096" cy="292608"/>
+          </a:xfrm>
+          <a:prstGeom prst="rect">
+            <a:avLst/>
+          </a:prstGeom>
+          <a:noFill/>
+          <a:ln/>
+        </p:spPr>
+        <p:txBody>
+          <a:bodyPr wrap="square" rtlCol="0" anchor="ctr"/>
+          <a:lstStyle/>
+          <a:p>
+            <a:pPr algn="l" indent="0" marL="0">
+              <a:buNone/>
+            </a:pPr>
+            <a:r>
+              <a:rPr lang="en-US" sz="1200" b="1" spc="400" kern="0" dirty="0">
+                <a:solidFill>
+                  <a:srgbClr val="EE0000"/>
+                </a:solidFill>
+                <a:latin typeface="Overpass" pitchFamily="34" charset="0"/>
+                <a:ea typeface="Overpass" pitchFamily="34" charset="-122"/>
+                <a:cs typeface="Overpass" pitchFamily="34" charset="-120"/>
+              </a:rPr>
+              <a:t>THE PIPELINE · PROFILING</a:t>
+            </a:r>
+            <a:endParaRPr lang="en-US" sz="1200" dirty="0"/>
+          </a:p>
+        </p:txBody>
+      </p:sp>
+      <p:sp>
+        <p:nvSpPr>
+          <p:cNvPr id="5" name="Text 2"/>
+          <p:cNvSpPr/>
+          <p:nvPr/>
+        </p:nvSpPr>
+        <p:spPr>
+          <a:xfrm>
+            <a:off x="566928" y="676656"/>
+            <a:ext cx="11055096" cy="1005840"/>
+          </a:xfrm>
+          <a:prstGeom prst="rect">
+            <a:avLst/>
+          </a:prstGeom>
+          <a:noFill/>
+          <a:ln/>
+        </p:spPr>
+        <p:txBody>
+          <a:bodyPr wrap="square" rtlCol="0" anchor="t"/>
+          <a:lstStyle/>
+          <a:p>
+            <a:pPr algn="l" indent="0" marL="0">
+              <a:buNone/>
+            </a:pPr>
+            <a:r>
+              <a:rPr lang="en-US" sz="3000" b="1" dirty="0">
+                <a:solidFill>
+                  <a:srgbClr val="151515"/>
+                </a:solidFill>
+                <a:latin typeface="Overpass" pitchFamily="34" charset="0"/>
+                <a:ea typeface="Overpass" pitchFamily="34" charset="-122"/>
+                <a:cs typeface="Overpass" pitchFamily="34" charset="-120"/>
+              </a:rPr>
+              <a:t>Bundled backend, unsettled client side</a:t>
+            </a:r>
+            <a:endParaRPr lang="en-US" sz="3000" dirty="0"/>
+          </a:p>
+        </p:txBody>
+      </p:sp>
+      <p:sp>
+        <p:nvSpPr>
+          <p:cNvPr id="6" name="Text 3"/>
+          <p:cNvSpPr/>
+          <p:nvPr/>
+        </p:nvSpPr>
+        <p:spPr>
+          <a:xfrm>
+            <a:off x="566928" y="1691640"/>
+            <a:ext cx="11055096" cy="4434840"/>
+          </a:xfrm>
+          <a:prstGeom prst="rect">
+            <a:avLst/>
+          </a:prstGeom>
+          <a:noFill/>
+          <a:ln/>
+        </p:spPr>
+        <p:txBody>
+          <a:bodyPr wrap="square" rtlCol="0" anchor="t"/>
+          <a:lstStyle/>
+          <a:p>
+            <a:pPr algn="l" marL="342900" indent="-342900">
+              <a:lnSpc>
+                <a:spcPct val="115000"/>
+              </a:lnSpc>
+              <a:spcAft>
+                <a:spcPts val="600"/>
+              </a:spcAft>
+              <a:buSzPct val="100000"/>
+              <a:buChar char="●"/>
+            </a:pPr>
+            <a:r>
+              <a:rPr lang="en-US" sz="1500" dirty="0">
+                <a:solidFill>
+                  <a:srgbClr val="242424"/>
+                </a:solidFill>
+                <a:latin typeface="Red Hat Text" pitchFamily="34" charset="0"/>
+                <a:ea typeface="Red Hat Text" pitchFamily="34" charset="-122"/>
+                <a:cs typeface="Red Hat Text" pitchFamily="34" charset="-120"/>
+              </a:rPr>
+              <a:t>Continuous profiling samples the call stack a few times a second at low overhead, always on, and aggregates it into a flame graph — the view traces, metrics, and logs cannot give, because they stop at the process boundary.</a:t>
+            </a:r>
+            <a:endParaRPr lang="en-US" sz="1500" dirty="0"/>
+          </a:p>
+          <a:p>
+            <a:pPr algn="l" marL="342900" indent="-342900">
+              <a:lnSpc>
+                <a:spcPct val="115000"/>
+              </a:lnSpc>
+              <a:spcAft>
+                <a:spcPts val="600"/>
+              </a:spcAft>
+              <a:buSzPct val="100000"/>
+              <a:buChar char="●"/>
+            </a:pPr>
+            <a:r>
+              <a:rPr lang="en-US" sz="1500" dirty="0">
+                <a:solidFill>
+                  <a:srgbClr val="242424"/>
+                </a:solidFill>
+                <a:latin typeface="Red Hat Text" pitchFamily="34" charset="0"/>
+                <a:ea typeface="Red Hat Text" pitchFamily="34" charset="-122"/>
+                <a:cs typeface="Red Hat Text" pitchFamily="34" charset="-120"/>
+              </a:rPr>
+              <a:t>The backend is already here: the otel-lgtm image bundles Pyroscope with a Collector profiles pipeline. The span→flame-graph link is Grafana's tracesToProfiles, matched on service + time.</a:t>
+            </a:r>
+            <a:endParaRPr lang="en-US" sz="1500" dirty="0"/>
+          </a:p>
+          <a:p>
+            <a:pPr algn="l" marL="342900" indent="-342900">
+              <a:lnSpc>
+                <a:spcPct val="115000"/>
+              </a:lnSpc>
+              <a:spcAft>
+                <a:spcPts val="600"/>
+              </a:spcAft>
+              <a:buSzPct val="100000"/>
+              <a:buChar char="●"/>
+            </a:pPr>
+            <a:r>
+              <a:rPr lang="en-US" sz="1500" dirty="0">
+                <a:solidFill>
+                  <a:srgbClr val="242424"/>
+                </a:solidFill>
+                <a:latin typeface="Red Hat Text" pitchFamily="34" charset="0"/>
+                <a:ea typeface="Red Hat Text" pitchFamily="34" charset="-122"/>
+                <a:cs typeface="Red Hat Text" pitchFamily="34" charset="-120"/>
+              </a:rPr>
+              <a:t>Honest caveats: the 0.8.1 image pin may predate Pyroscope (bump it); the mounted Collector config must add a profiles pipeline back; and the Python OTLP-profiles signal is still experimental, so the Pyroscope SDK is the pragmatic path today. This is the least-settled signal in the stack.</a:t>
+            </a:r>
+            <a:endParaRPr lang="en-US" sz="1500" dirty="0"/>
+          </a:p>
+        </p:txBody>
+      </p:sp>
+    </p:spTree>
+  </p:cSld>
+  <p:clrMapOvr>
+    <a:masterClrMapping/>
+  </p:clrMapOvr>
+</p:sld>
+</file>
+
+<file path=ppt/slides/slide39.xml><?xml version="1.0" encoding="utf-8"?>
+<p:sld xmlns:a="http://schemas.openxmlformats.org/drawingml/2006/main" xmlns:r="http://schemas.openxmlformats.org/officeDocument/2006/relationships" xmlns:p="http://schemas.openxmlformats.org/presentationml/2006/main">
+  <p:cSld name="Slide 39">
+    <p:spTree>
+      <p:nvGrpSpPr>
+        <p:cNvPr id="1" name=""/>
+        <p:cNvGrpSpPr/>
+        <p:nvPr/>
+      </p:nvGrpSpPr>
+      <p:grpSpPr>
+        <a:xfrm>
+          <a:off x="0" y="0"/>
+          <a:ext cx="0" cy="0"/>
+          <a:chOff x="0" y="0"/>
+          <a:chExt cx="0" cy="0"/>
+        </a:xfrm>
+      </p:grpSpPr>
+      <p:sp>
+        <p:nvSpPr>
+          <p:cNvPr id="2" name="Text 0"/>
+          <p:cNvSpPr/>
+          <p:nvPr/>
+        </p:nvSpPr>
+        <p:spPr>
+          <a:xfrm>
+            <a:off x="566928" y="6364224"/>
+            <a:ext cx="914400" cy="274320"/>
+          </a:xfrm>
+          <a:prstGeom prst="rect">
+            <a:avLst/>
+          </a:prstGeom>
+          <a:noFill/>
+          <a:ln/>
+        </p:spPr>
+        <p:txBody>
+          <a:bodyPr wrap="square" rtlCol="0" anchor="ctr"/>
+          <a:lstStyle/>
+          <a:p>
+            <a:pPr algn="l" indent="0" marL="0">
+              <a:buNone/>
+            </a:pPr>
+            <a:r>
+              <a:rPr lang="en-US" sz="1000" dirty="0">
+                <a:solidFill>
+                  <a:srgbClr val="8A8A8A"/>
+                </a:solidFill>
+                <a:latin typeface="Red Hat Text" pitchFamily="34" charset="0"/>
+                <a:ea typeface="Red Hat Text" pitchFamily="34" charset="-122"/>
+                <a:cs typeface="Red Hat Text" pitchFamily="34" charset="-120"/>
+              </a:rPr>
+              <a:t>39</a:t>
+            </a:r>
+            <a:endParaRPr lang="en-US" sz="1000" dirty="0"/>
+          </a:p>
+        </p:txBody>
+      </p:sp>
+      <p:pic>
+        <p:nvPicPr>
+          <p:cNvPr id="3" name="Image 0" descr="./assets/logo-candidate-2.png">    </p:cNvPr>
+          <p:cNvPicPr>
+            <a:picLocks noChangeAspect="1"/>
+          </p:cNvPicPr>
+          <p:nvPr/>
+        </p:nvPicPr>
+        <p:blipFill>
+          <a:blip r:embed="rId1"/>
+          <a:stretch>
+            <a:fillRect/>
+          </a:stretch>
+        </p:blipFill>
+        <p:spPr>
+          <a:xfrm>
+            <a:off x="10561320" y="6355080"/>
+            <a:ext cx="1033272" cy="246888"/>
+          </a:xfrm>
+          <a:prstGeom prst="rect">
+            <a:avLst/>
+          </a:prstGeom>
+        </p:spPr>
+      </p:pic>
+      <p:sp>
+        <p:nvSpPr>
+          <p:cNvPr id="4" name="Text 1"/>
+          <p:cNvSpPr/>
+          <p:nvPr/>
+        </p:nvSpPr>
+        <p:spPr>
+          <a:xfrm>
+            <a:off x="566928" y="384048"/>
+            <a:ext cx="11055096" cy="292608"/>
+          </a:xfrm>
+          <a:prstGeom prst="rect">
+            <a:avLst/>
+          </a:prstGeom>
+          <a:noFill/>
+          <a:ln/>
+        </p:spPr>
+        <p:txBody>
+          <a:bodyPr wrap="square" rtlCol="0" anchor="ctr"/>
+          <a:lstStyle/>
+          <a:p>
+            <a:pPr algn="l" indent="0" marL="0">
+              <a:buNone/>
+            </a:pPr>
+            <a:r>
+              <a:rPr lang="en-US" sz="1200" b="1" spc="400" kern="0" dirty="0">
+                <a:solidFill>
+                  <a:srgbClr val="EE0000"/>
+                </a:solidFill>
+                <a:latin typeface="Overpass" pitchFamily="34" charset="0"/>
+                <a:ea typeface="Overpass" pitchFamily="34" charset="-122"/>
+                <a:cs typeface="Overpass" pitchFamily="34" charset="-120"/>
+              </a:rPr>
+              <a:t>WRAP-UP</a:t>
+            </a:r>
+            <a:endParaRPr lang="en-US" sz="1200" dirty="0"/>
+          </a:p>
+        </p:txBody>
+      </p:sp>
+      <p:sp>
+        <p:nvSpPr>
+          <p:cNvPr id="5" name="Text 2"/>
+          <p:cNvSpPr/>
+          <p:nvPr/>
+        </p:nvSpPr>
+        <p:spPr>
+          <a:xfrm>
+            <a:off x="566928" y="676656"/>
+            <a:ext cx="11055096" cy="1005840"/>
+          </a:xfrm>
+          <a:prstGeom prst="rect">
+            <a:avLst/>
+          </a:prstGeom>
+          <a:noFill/>
+          <a:ln/>
+        </p:spPr>
+        <p:txBody>
+          <a:bodyPr wrap="square" rtlCol="0" anchor="t"/>
+          <a:lstStyle/>
+          <a:p>
+            <a:pPr algn="l" indent="0" marL="0">
+              <a:buNone/>
+            </a:pPr>
+            <a:r>
+              <a:rPr lang="en-US" sz="3000" b="1" dirty="0">
+                <a:solidFill>
+                  <a:srgbClr val="151515"/>
+                </a:solidFill>
+                <a:latin typeface="Overpass" pitchFamily="34" charset="0"/>
+                <a:ea typeface="Overpass" pitchFamily="34" charset="-122"/>
+                <a:cs typeface="Overpass" pitchFamily="34" charset="-120"/>
+              </a:rPr>
+              <a:t>One request, four signals, end to end</a:t>
+            </a:r>
+            <a:endParaRPr lang="en-US" sz="3000" dirty="0"/>
+          </a:p>
+        </p:txBody>
+      </p:sp>
+      <p:sp>
+        <p:nvSpPr>
+          <p:cNvPr id="6" name="Text 3"/>
+          <p:cNvSpPr/>
+          <p:nvPr/>
+        </p:nvSpPr>
+        <p:spPr>
+          <a:xfrm>
+            <a:off x="566928" y="1691640"/>
+            <a:ext cx="11055096" cy="4434840"/>
+          </a:xfrm>
+          <a:prstGeom prst="rect">
+            <a:avLst/>
+          </a:prstGeom>
+          <a:noFill/>
+          <a:ln/>
+        </p:spPr>
+        <p:txBody>
+          <a:bodyPr wrap="square" rtlCol="0" anchor="t"/>
+          <a:lstStyle/>
+          <a:p>
+            <a:pPr algn="l" marL="342900" indent="-342900">
+              <a:lnSpc>
+                <a:spcPct val="115000"/>
+              </a:lnSpc>
+              <a:spcAft>
+                <a:spcPts val="600"/>
+              </a:spcAft>
+              <a:buSzPct val="100000"/>
+              <a:buChar char="●"/>
+            </a:pPr>
+            <a:r>
+              <a:rPr lang="en-US" sz="1500" dirty="0">
+                <a:solidFill>
+                  <a:srgbClr val="242424"/>
+                </a:solidFill>
+                <a:latin typeface="Red Hat Text" pitchFamily="34" charset="0"/>
+                <a:ea typeface="Red Hat Text" pitchFamily="34" charset="-122"/>
+                <a:cs typeface="Red Hat Text" pitchFamily="34" charset="-120"/>
+              </a:rPr>
+              <a:t>The full correlation story across the services: traces across REST and gRPC for free, metrics with exemplars, logs stamped with the trace_id, custom spans that carry the trace across Kafka, the honest auto/custom/hybrid trade-off, and a Grafana walkthrough that pivots trace → logs → metrics on one click.</a:t>
+            </a:r>
+            <a:endParaRPr lang="en-US" sz="1500" dirty="0"/>
+          </a:p>
+          <a:p>
+            <a:pPr algn="l" marL="342900" indent="-342900">
+              <a:lnSpc>
+                <a:spcPct val="115000"/>
+              </a:lnSpc>
+              <a:spcAft>
+                <a:spcPts val="600"/>
+              </a:spcAft>
+              <a:buSzPct val="100000"/>
+              <a:buChar char="●"/>
+            </a:pPr>
+            <a:r>
+              <a:rPr lang="en-US" sz="1500" dirty="0">
+                <a:solidFill>
+                  <a:srgbClr val="242424"/>
+                </a:solidFill>
+                <a:latin typeface="Red Hat Text" pitchFamily="34" charset="0"/>
+                <a:ea typeface="Red Hat Text" pitchFamily="34" charset="-122"/>
+                <a:cs typeface="Red Hat Text" pitchFamily="34" charset="-120"/>
+              </a:rPr>
+              <a:t>The pipeline part moved the costly decisions into the Collector: tail sampling that keeps errors, slow, and critical routes at volume while the app stays out of the sampling business — and continuous profiling as the fourth signal, where the CPU goes inside a slow span.</a:t>
+            </a:r>
+            <a:endParaRPr lang="en-US" sz="1500" dirty="0"/>
+          </a:p>
+          <a:p>
+            <a:pPr algn="l" marL="342900" indent="-342900">
+              <a:lnSpc>
+                <a:spcPct val="115000"/>
+              </a:lnSpc>
+              <a:spcAft>
+                <a:spcPts val="600"/>
+              </a:spcAft>
+              <a:buSzPct val="100000"/>
+              <a:buChar char="●"/>
+            </a:pPr>
+            <a:r>
+              <a:rPr lang="en-US" sz="1500" dirty="0">
+                <a:solidFill>
+                  <a:srgbClr val="242424"/>
+                </a:solidFill>
+                <a:latin typeface="Red Hat Text" pitchFamily="34" charset="0"/>
+                <a:ea typeface="Red Hat Text" pitchFamily="34" charset="-122"/>
+                <a:cs typeface="Red Hat Text" pitchFamily="34" charset="-120"/>
+              </a:rPr>
+              <a:t>The tutorial mirrors these slides chapter for chapter (§0–§11), with six example services, the shared protos and obs library, and a runnable demo per chapter. It is authored against the target versions but not yet run end to end — it ships marked unverified, and a live rehearsal against the real stack is the next milestone.</a:t>
             </a:r>
             <a:endParaRPr lang="en-US" sz="1500" dirty="0"/>
           </a:p>

</xml_diff>

<commit_message>
r1.15: deck — add live service graph slides (fig-13) to the pipeline section; close the lockstep
</commit_message>
<xml_diff>
--- a/presentations/otel-lgtm-python.pptx
+++ b/presentations/otel-lgtm-python.pptx
@@ -44,9 +44,11 @@
     <p:sldId id="292" r:id="rId38"/>
     <p:sldId id="293" r:id="rId39"/>
     <p:sldId id="294" r:id="rId40"/>
+    <p:sldId id="295" r:id="rId41"/>
+    <p:sldId id="296" r:id="rId42"/>
   </p:sldIdLst>
   <p:notesMasterIdLst>
-    <p:notesMasterId r:id="rId41"/>
+    <p:notesMasterId r:id="rId43"/>
   </p:notesMasterIdLst>
   <p:sldSz cx="12192000" cy="6858000"/>
   <p:notesSz cx="6858000" cy="12192000"/>
@@ -3356,7 +3358,7 @@
           <a:p>
             <a:r>
               <a:rPr lang="en-US" dirty="0"/>
-              <a:t>Re-walk the whole arc so the audience knows what they hold. Foundations gave them the services and the model; the three signals gave them the correlated signals, their cost, and the one-click view; the pipeline kept it affordable at volume and added the fourth signal. Be honest about iteration state: this is authored against the target versions but not yet run end-to-end here, so it ships marked unverified, and a live rehearsal is the next milestone. Point people at the repo — the tutorial mirrors these slides chapter for chapter, and every example has a runnable demo.sh.</a:t>
+              <a:t>The operational, all-requests-at-once view — same correlation idea one level up: instead of one trace, the shape of all of them. Stress that it's trace-derived: the edges come from client/server and producer/consumer span kinds and db.* attributes, which is exactly why it needs no service mesh or sidecars.</a:t>
             </a:r>
             <a:endParaRPr lang="en-US" dirty="0"/>
           </a:p>
@@ -3468,6 +3470,182 @@
             <a:fld id="{F7021451-1387-4CA6-816F-3879F97B5CBC}" type="slidenum">
               <a:rPr lang="en-US"/>
               <a:t>4</a:t>
+            </a:fld>
+            <a:endParaRPr lang="en-US"/>
+          </a:p>
+        </p:txBody>
+      </p:sp>
+    </p:spTree>
+    <p:extLst>
+      <p:ext uri="{BB962C8B-B14F-4D97-AF65-F5344CB8AC3E}">
+        <p14:creationId xmlns:p14="http://schemas.microsoft.com/office/powerpoint/2010/main" val="1024086991"/>
+      </p:ext>
+    </p:extLst>
+  </p:cSld>
+  <p:clrMapOvr>
+    <a:masterClrMapping/>
+  </p:clrMapOvr>
+</p:notes>
+</file>
+
+<file path=ppt/notesSlides/notesSlide40.xml><?xml version="1.0" encoding="utf-8"?>
+<p:notes xmlns:a="http://schemas.openxmlformats.org/drawingml/2006/main" xmlns:r="http://schemas.openxmlformats.org/officeDocument/2006/relationships" xmlns:p="http://schemas.openxmlformats.org/presentationml/2006/main">
+  <p:cSld>
+    <p:spTree>
+      <p:nvGrpSpPr>
+        <p:cNvPr id="1" name=""/>
+        <p:cNvGrpSpPr/>
+        <p:nvPr/>
+      </p:nvGrpSpPr>
+      <p:grpSpPr>
+        <a:xfrm>
+          <a:off x="0" y="0"/>
+          <a:ext cx="0" cy="0"/>
+          <a:chOff x="0" y="0"/>
+          <a:chExt cx="0" cy="0"/>
+        </a:xfrm>
+      </p:grpSpPr>
+      <p:sp>
+        <p:nvSpPr>
+          <p:cNvPr id="2" name="Slide Image Placeholder 1"/>
+          <p:cNvSpPr>
+            <a:spLocks noGrp="1" noRot="1" noChangeAspect="1"/>
+          </p:cNvSpPr>
+          <p:nvPr>
+            <p:ph type="sldImg"/>
+          </p:nvPr>
+        </p:nvSpPr>
+        <p:spPr/>
+      </p:sp>
+      <p:sp>
+        <p:nvSpPr>
+          <p:cNvPr id="3" name="Notes Placeholder 2"/>
+          <p:cNvSpPr>
+            <a:spLocks noGrp="1"/>
+          </p:cNvSpPr>
+          <p:nvPr>
+            <p:ph type="body" idx="1"/>
+          </p:nvPr>
+        </p:nvSpPr>
+        <p:spPr/>
+        <p:txBody>
+          <a:bodyPr/>
+          <a:lstStyle/>
+          <a:p>
+            <a:r>
+              <a:rPr lang="en-US" dirty="0"/>
+              <a:t>This is the answer to 'can we see what's happening live?' without adopting Istio. The Kafka edge only appears if propagation is on (Demo 2) — a missing shipping/notification edge is the broken async link from §7, seen from above. The Grafana service map is provisioned; the Tempo generator enablement is the version-sensitive bit to confirm.</a:t>
+            </a:r>
+            <a:endParaRPr lang="en-US" dirty="0"/>
+          </a:p>
+        </p:txBody>
+      </p:sp>
+      <p:sp>
+        <p:nvSpPr>
+          <p:cNvPr id="4" name="Slide Number Placeholder 3"/>
+          <p:cNvSpPr>
+            <a:spLocks noGrp="1"/>
+          </p:cNvSpPr>
+          <p:nvPr>
+            <p:ph type="sldNum" sz="quarter" idx="10"/>
+          </p:nvPr>
+        </p:nvSpPr>
+        <p:spPr/>
+        <p:txBody>
+          <a:bodyPr/>
+          <a:lstStyle/>
+          <a:p>
+            <a:fld id="{F7021451-1387-4CA6-816F-3879F97B5CBC}" type="slidenum">
+              <a:rPr lang="en-US"/>
+              <a:t>40</a:t>
+            </a:fld>
+            <a:endParaRPr lang="en-US"/>
+          </a:p>
+        </p:txBody>
+      </p:sp>
+    </p:spTree>
+    <p:extLst>
+      <p:ext uri="{BB962C8B-B14F-4D97-AF65-F5344CB8AC3E}">
+        <p14:creationId xmlns:p14="http://schemas.microsoft.com/office/powerpoint/2010/main" val="1024086991"/>
+      </p:ext>
+    </p:extLst>
+  </p:cSld>
+  <p:clrMapOvr>
+    <a:masterClrMapping/>
+  </p:clrMapOvr>
+</p:notes>
+</file>
+
+<file path=ppt/notesSlides/notesSlide41.xml><?xml version="1.0" encoding="utf-8"?>
+<p:notes xmlns:a="http://schemas.openxmlformats.org/drawingml/2006/main" xmlns:r="http://schemas.openxmlformats.org/officeDocument/2006/relationships" xmlns:p="http://schemas.openxmlformats.org/presentationml/2006/main">
+  <p:cSld>
+    <p:spTree>
+      <p:nvGrpSpPr>
+        <p:cNvPr id="1" name=""/>
+        <p:cNvGrpSpPr/>
+        <p:nvPr/>
+      </p:nvGrpSpPr>
+      <p:grpSpPr>
+        <a:xfrm>
+          <a:off x="0" y="0"/>
+          <a:ext cx="0" cy="0"/>
+          <a:chOff x="0" y="0"/>
+          <a:chExt cx="0" cy="0"/>
+        </a:xfrm>
+      </p:grpSpPr>
+      <p:sp>
+        <p:nvSpPr>
+          <p:cNvPr id="2" name="Slide Image Placeholder 1"/>
+          <p:cNvSpPr>
+            <a:spLocks noGrp="1" noRot="1" noChangeAspect="1"/>
+          </p:cNvSpPr>
+          <p:nvPr>
+            <p:ph type="sldImg"/>
+          </p:nvPr>
+        </p:nvSpPr>
+        <p:spPr/>
+      </p:sp>
+      <p:sp>
+        <p:nvSpPr>
+          <p:cNvPr id="3" name="Notes Placeholder 2"/>
+          <p:cNvSpPr>
+            <a:spLocks noGrp="1"/>
+          </p:cNvSpPr>
+          <p:nvPr>
+            <p:ph type="body" idx="1"/>
+          </p:nvPr>
+        </p:nvSpPr>
+        <p:spPr/>
+        <p:txBody>
+          <a:bodyPr/>
+          <a:lstStyle/>
+          <a:p>
+            <a:r>
+              <a:rPr lang="en-US" dirty="0"/>
+              <a:t>Re-walk the whole arc so the audience knows what they hold. Foundations gave them the services and the model; the three signals gave them the correlated signals, their cost, and the one-click view; the pipeline kept it affordable at volume and added the fourth signal. Be honest about iteration state: this is authored against the target versions but not yet run end-to-end here, so it ships marked unverified, and a live rehearsal is the next milestone. Point people at the repo — the tutorial mirrors these slides chapter for chapter, and every example has a runnable demo.sh.</a:t>
+            </a:r>
+            <a:endParaRPr lang="en-US" dirty="0"/>
+          </a:p>
+        </p:txBody>
+      </p:sp>
+      <p:sp>
+        <p:nvSpPr>
+          <p:cNvPr id="4" name="Slide Number Placeholder 3"/>
+          <p:cNvSpPr>
+            <a:spLocks noGrp="1"/>
+          </p:cNvSpPr>
+          <p:nvPr>
+            <p:ph type="sldNum" sz="quarter" idx="10"/>
+          </p:nvPr>
+        </p:nvSpPr>
+        <p:spPr/>
+        <p:txBody>
+          <a:bodyPr/>
+          <a:lstStyle/>
+          <a:p>
+            <a:fld id="{F7021451-1387-4CA6-816F-3879F97B5CBC}" type="slidenum">
+              <a:rPr lang="en-US"/>
+              <a:t>41</a:t>
             </a:fld>
             <a:endParaRPr lang="en-US"/>
           </a:p>
@@ -13756,7 +13934,7 @@
                 <a:ea typeface="Overpass" pitchFamily="34" charset="-122"/>
                 <a:cs typeface="Overpass" pitchFamily="34" charset="-120"/>
               </a:rPr>
-              <a:t>WRAP-UP</a:t>
+              <a:t>THE PIPELINE · LIVE SERVICE GRAPH</a:t>
             </a:r>
             <a:endParaRPr lang="en-US" sz="1200" dirty="0"/>
           </a:p>
@@ -13795,22 +13973,45 @@
                 <a:ea typeface="Overpass" pitchFamily="34" charset="-122"/>
                 <a:cs typeface="Overpass" pitchFamily="34" charset="-120"/>
               </a:rPr>
-              <a:t>One request, four signals, end to end</a:t>
+              <a:t>What's going on right now</a:t>
             </a:r>
             <a:endParaRPr lang="en-US" sz="3000" dirty="0"/>
           </a:p>
         </p:txBody>
       </p:sp>
-      <p:sp>
-        <p:nvSpPr>
-          <p:cNvPr id="6" name="Text 3"/>
+      <p:pic>
+        <p:nvPicPr>
+          <p:cNvPr id="6" name="Image 1" descr="./png/fig-13-service-graph.png">    </p:cNvPr>
+          <p:cNvPicPr>
+            <a:picLocks noChangeAspect="1"/>
+          </p:cNvPicPr>
+          <p:nvPr/>
+        </p:nvPicPr>
+        <p:blipFill>
+          <a:blip r:embed="rId2"/>
+          <a:srcRect l="0" r="0" t="0" b="0"/>
+          <a:stretch/>
+        </p:blipFill>
+        <p:spPr>
+          <a:xfrm>
+            <a:off x="1645920" y="1600200"/>
+            <a:ext cx="8906256" cy="4343400"/>
+          </a:xfrm>
+          <a:prstGeom prst="rect">
+            <a:avLst/>
+          </a:prstGeom>
+        </p:spPr>
+      </p:pic>
+      <p:sp>
+        <p:nvSpPr>
+          <p:cNvPr id="7" name="Text 3"/>
           <p:cNvSpPr/>
           <p:nvPr/>
         </p:nvSpPr>
         <p:spPr>
           <a:xfrm>
-            <a:off x="566928" y="1691640"/>
-            <a:ext cx="11055096" cy="4434840"/>
+            <a:off x="566928" y="5943600"/>
+            <a:ext cx="11055096" cy="310896"/>
           </a:xfrm>
           <a:prstGeom prst="rect">
             <a:avLst/>
@@ -13819,79 +14020,24 @@
           <a:ln/>
         </p:spPr>
         <p:txBody>
-          <a:bodyPr wrap="square" rtlCol="0" anchor="t"/>
-          <a:lstStyle/>
-          <a:p>
-            <a:pPr algn="l" marL="342900" indent="-342900">
-              <a:lnSpc>
-                <a:spcPct val="115000"/>
-              </a:lnSpc>
-              <a:spcAft>
-                <a:spcPts val="600"/>
-              </a:spcAft>
-              <a:buSzPct val="100000"/>
-              <a:buChar char="●"/>
-            </a:pPr>
-            <a:r>
-              <a:rPr lang="en-US" sz="1500" dirty="0">
-                <a:solidFill>
-                  <a:srgbClr val="242424"/>
+          <a:bodyPr wrap="square" rtlCol="0" anchor="ctr"/>
+          <a:lstStyle/>
+          <a:p>
+            <a:pPr algn="ctr" indent="0" marL="0">
+              <a:buNone/>
+            </a:pPr>
+            <a:r>
+              <a:rPr lang="en-US" sz="1300" i="1" dirty="0">
+                <a:solidFill>
+                  <a:srgbClr val="5A5A5A"/>
                 </a:solidFill>
                 <a:latin typeface="Red Hat Text" pitchFamily="34" charset="0"/>
                 <a:ea typeface="Red Hat Text" pitchFamily="34" charset="-122"/>
                 <a:cs typeface="Red Hat Text" pitchFamily="34" charset="-120"/>
               </a:rPr>
-              <a:t>The full correlation story across the services: traces across REST and gRPC for free, metrics with exemplars, logs stamped with the trace_id, custom spans that carry the trace across Kafka, the honest auto/custom/hybrid trade-off, and a Grafana walkthrough that pivots trace → logs → metrics on one click.</a:t>
-            </a:r>
-            <a:endParaRPr lang="en-US" sz="1500" dirty="0"/>
-          </a:p>
-          <a:p>
-            <a:pPr algn="l" marL="342900" indent="-342900">
-              <a:lnSpc>
-                <a:spcPct val="115000"/>
-              </a:lnSpc>
-              <a:spcAft>
-                <a:spcPts val="600"/>
-              </a:spcAft>
-              <a:buSzPct val="100000"/>
-              <a:buChar char="●"/>
-            </a:pPr>
-            <a:r>
-              <a:rPr lang="en-US" sz="1500" dirty="0">
-                <a:solidFill>
-                  <a:srgbClr val="242424"/>
-                </a:solidFill>
-                <a:latin typeface="Red Hat Text" pitchFamily="34" charset="0"/>
-                <a:ea typeface="Red Hat Text" pitchFamily="34" charset="-122"/>
-                <a:cs typeface="Red Hat Text" pitchFamily="34" charset="-120"/>
-              </a:rPr>
-              <a:t>The pipeline part moved the costly decisions into the Collector: tail sampling that keeps errors, slow, and critical routes at volume while the app stays out of the sampling business — and continuous profiling as the fourth signal, where the CPU goes inside a slow span.</a:t>
-            </a:r>
-            <a:endParaRPr lang="en-US" sz="1500" dirty="0"/>
-          </a:p>
-          <a:p>
-            <a:pPr algn="l" marL="342900" indent="-342900">
-              <a:lnSpc>
-                <a:spcPct val="115000"/>
-              </a:lnSpc>
-              <a:spcAft>
-                <a:spcPts val="600"/>
-              </a:spcAft>
-              <a:buSzPct val="100000"/>
-              <a:buChar char="●"/>
-            </a:pPr>
-            <a:r>
-              <a:rPr lang="en-US" sz="1500" dirty="0">
-                <a:solidFill>
-                  <a:srgbClr val="242424"/>
-                </a:solidFill>
-                <a:latin typeface="Red Hat Text" pitchFamily="34" charset="0"/>
-                <a:ea typeface="Red Hat Text" pitchFamily="34" charset="-122"/>
-                <a:cs typeface="Red Hat Text" pitchFamily="34" charset="-120"/>
-              </a:rPr>
-              <a:t>The tutorial mirrors these slides chapter for chapter (§0–§11), with six example services, the shared protos and obs library, and a runnable demo per chapter. It is authored against the target versions but not yet run end to end — it ships marked unverified, and a live rehearsal against the real stack is the next milestone.</a:t>
-            </a:r>
-            <a:endParaRPr lang="en-US" sz="1500" dirty="0"/>
+              <a:t>Figure 12.1 — The topology with live request, error, and latency on every edge — built from traces by Tempo's metrics-generator, no mesh required.</a:t>
+            </a:r>
+            <a:endParaRPr lang="en-US" sz="1300" dirty="0"/>
           </a:p>
         </p:txBody>
       </p:sp>
@@ -14719,6 +14865,526 @@
               <a:t>Foundations is this part; the three signals and the pipeline are the two halves that follow.</a:t>
             </a:r>
             <a:endParaRPr lang="en-US" sz="1300" dirty="0"/>
+          </a:p>
+        </p:txBody>
+      </p:sp>
+    </p:spTree>
+  </p:cSld>
+  <p:clrMapOvr>
+    <a:masterClrMapping/>
+  </p:clrMapOvr>
+</p:sld>
+</file>
+
+<file path=ppt/slides/slide40.xml><?xml version="1.0" encoding="utf-8"?>
+<p:sld xmlns:a="http://schemas.openxmlformats.org/drawingml/2006/main" xmlns:r="http://schemas.openxmlformats.org/officeDocument/2006/relationships" xmlns:p="http://schemas.openxmlformats.org/presentationml/2006/main">
+  <p:cSld name="Slide 40">
+    <p:spTree>
+      <p:nvGrpSpPr>
+        <p:cNvPr id="1" name=""/>
+        <p:cNvGrpSpPr/>
+        <p:nvPr/>
+      </p:nvGrpSpPr>
+      <p:grpSpPr>
+        <a:xfrm>
+          <a:off x="0" y="0"/>
+          <a:ext cx="0" cy="0"/>
+          <a:chOff x="0" y="0"/>
+          <a:chExt cx="0" cy="0"/>
+        </a:xfrm>
+      </p:grpSpPr>
+      <p:sp>
+        <p:nvSpPr>
+          <p:cNvPr id="2" name="Text 0"/>
+          <p:cNvSpPr/>
+          <p:nvPr/>
+        </p:nvSpPr>
+        <p:spPr>
+          <a:xfrm>
+            <a:off x="566928" y="6364224"/>
+            <a:ext cx="914400" cy="274320"/>
+          </a:xfrm>
+          <a:prstGeom prst="rect">
+            <a:avLst/>
+          </a:prstGeom>
+          <a:noFill/>
+          <a:ln/>
+        </p:spPr>
+        <p:txBody>
+          <a:bodyPr wrap="square" rtlCol="0" anchor="ctr"/>
+          <a:lstStyle/>
+          <a:p>
+            <a:pPr algn="l" indent="0" marL="0">
+              <a:buNone/>
+            </a:pPr>
+            <a:r>
+              <a:rPr lang="en-US" sz="1000" dirty="0">
+                <a:solidFill>
+                  <a:srgbClr val="8A8A8A"/>
+                </a:solidFill>
+                <a:latin typeface="Red Hat Text" pitchFamily="34" charset="0"/>
+                <a:ea typeface="Red Hat Text" pitchFamily="34" charset="-122"/>
+                <a:cs typeface="Red Hat Text" pitchFamily="34" charset="-120"/>
+              </a:rPr>
+              <a:t>40</a:t>
+            </a:r>
+            <a:endParaRPr lang="en-US" sz="1000" dirty="0"/>
+          </a:p>
+        </p:txBody>
+      </p:sp>
+      <p:pic>
+        <p:nvPicPr>
+          <p:cNvPr id="3" name="Image 0" descr="./assets/logo-candidate-2.png">    </p:cNvPr>
+          <p:cNvPicPr>
+            <a:picLocks noChangeAspect="1"/>
+          </p:cNvPicPr>
+          <p:nvPr/>
+        </p:nvPicPr>
+        <p:blipFill>
+          <a:blip r:embed="rId1"/>
+          <a:stretch>
+            <a:fillRect/>
+          </a:stretch>
+        </p:blipFill>
+        <p:spPr>
+          <a:xfrm>
+            <a:off x="10561320" y="6355080"/>
+            <a:ext cx="1033272" cy="246888"/>
+          </a:xfrm>
+          <a:prstGeom prst="rect">
+            <a:avLst/>
+          </a:prstGeom>
+        </p:spPr>
+      </p:pic>
+      <p:sp>
+        <p:nvSpPr>
+          <p:cNvPr id="4" name="Text 1"/>
+          <p:cNvSpPr/>
+          <p:nvPr/>
+        </p:nvSpPr>
+        <p:spPr>
+          <a:xfrm>
+            <a:off x="566928" y="384048"/>
+            <a:ext cx="11055096" cy="292608"/>
+          </a:xfrm>
+          <a:prstGeom prst="rect">
+            <a:avLst/>
+          </a:prstGeom>
+          <a:noFill/>
+          <a:ln/>
+        </p:spPr>
+        <p:txBody>
+          <a:bodyPr wrap="square" rtlCol="0" anchor="ctr"/>
+          <a:lstStyle/>
+          <a:p>
+            <a:pPr algn="l" indent="0" marL="0">
+              <a:buNone/>
+            </a:pPr>
+            <a:r>
+              <a:rPr lang="en-US" sz="1200" b="1" spc="400" kern="0" dirty="0">
+                <a:solidFill>
+                  <a:srgbClr val="EE0000"/>
+                </a:solidFill>
+                <a:latin typeface="Overpass" pitchFamily="34" charset="0"/>
+                <a:ea typeface="Overpass" pitchFamily="34" charset="-122"/>
+                <a:cs typeface="Overpass" pitchFamily="34" charset="-120"/>
+              </a:rPr>
+              <a:t>THE PIPELINE · LIVE SERVICE GRAPH</a:t>
+            </a:r>
+            <a:endParaRPr lang="en-US" sz="1200" dirty="0"/>
+          </a:p>
+        </p:txBody>
+      </p:sp>
+      <p:sp>
+        <p:nvSpPr>
+          <p:cNvPr id="5" name="Text 2"/>
+          <p:cNvSpPr/>
+          <p:nvPr/>
+        </p:nvSpPr>
+        <p:spPr>
+          <a:xfrm>
+            <a:off x="566928" y="676656"/>
+            <a:ext cx="11055096" cy="1005840"/>
+          </a:xfrm>
+          <a:prstGeom prst="rect">
+            <a:avLst/>
+          </a:prstGeom>
+          <a:noFill/>
+          <a:ln/>
+        </p:spPr>
+        <p:txBody>
+          <a:bodyPr wrap="square" rtlCol="0" anchor="t"/>
+          <a:lstStyle/>
+          <a:p>
+            <a:pPr algn="l" indent="0" marL="0">
+              <a:buNone/>
+            </a:pPr>
+            <a:r>
+              <a:rPr lang="en-US" sz="3000" b="1" dirty="0">
+                <a:solidFill>
+                  <a:srgbClr val="151515"/>
+                </a:solidFill>
+                <a:latin typeface="Overpass" pitchFamily="34" charset="0"/>
+                <a:ea typeface="Overpass" pitchFamily="34" charset="-122"/>
+                <a:cs typeface="Overpass" pitchFamily="34" charset="-120"/>
+              </a:rPr>
+              <a:t>The Kiali view, without the mesh</a:t>
+            </a:r>
+            <a:endParaRPr lang="en-US" sz="3000" dirty="0"/>
+          </a:p>
+        </p:txBody>
+      </p:sp>
+      <p:sp>
+        <p:nvSpPr>
+          <p:cNvPr id="6" name="Text 3"/>
+          <p:cNvSpPr/>
+          <p:nvPr/>
+        </p:nvSpPr>
+        <p:spPr>
+          <a:xfrm>
+            <a:off x="566928" y="1691640"/>
+            <a:ext cx="11055096" cy="4434840"/>
+          </a:xfrm>
+          <a:prstGeom prst="rect">
+            <a:avLst/>
+          </a:prstGeom>
+          <a:noFill/>
+          <a:ln/>
+        </p:spPr>
+        <p:txBody>
+          <a:bodyPr wrap="square" rtlCol="0" anchor="t"/>
+          <a:lstStyle/>
+          <a:p>
+            <a:pPr algn="l" marL="342900" indent="-342900">
+              <a:lnSpc>
+                <a:spcPct val="115000"/>
+              </a:lnSpc>
+              <a:spcAft>
+                <a:spcPts val="600"/>
+              </a:spcAft>
+              <a:buSzPct val="100000"/>
+              <a:buChar char="●"/>
+            </a:pPr>
+            <a:r>
+              <a:rPr lang="en-US" sz="1500" dirty="0">
+                <a:solidFill>
+                  <a:srgbClr val="242424"/>
+                </a:solidFill>
+                <a:latin typeface="Red Hat Text" pitchFamily="34" charset="0"/>
+                <a:ea typeface="Red Hat Text" pitchFamily="34" charset="-122"/>
+                <a:cs typeface="Red Hat Text" pitchFamily="34" charset="-120"/>
+              </a:rPr>
+              <a:t>Tempo's metrics-generator reads span relationships — client/server calls, producer/consumer hops, db.* attributes — and emits service-graph and span metrics; Grafana renders them as a node graph with live RED on every node and edge.</a:t>
+            </a:r>
+            <a:endParaRPr lang="en-US" sz="1500" dirty="0"/>
+          </a:p>
+          <a:p>
+            <a:pPr algn="l" marL="342900" indent="-342900">
+              <a:lnSpc>
+                <a:spcPct val="115000"/>
+              </a:lnSpc>
+              <a:spcAft>
+                <a:spcPts val="600"/>
+              </a:spcAft>
+              <a:buSzPct val="100000"/>
+              <a:buChar char="●"/>
+            </a:pPr>
+            <a:r>
+              <a:rPr lang="en-US" sz="1500" dirty="0">
+                <a:solidFill>
+                  <a:srgbClr val="242424"/>
+                </a:solidFill>
+                <a:latin typeface="Red Hat Text" pitchFamily="34" charset="0"/>
+                <a:ea typeface="Red Hat Text" pitchFamily="34" charset="-122"/>
+                <a:cs typeface="Red Hat Text" pitchFamily="34" charset="-120"/>
+              </a:rPr>
+              <a:t>That's exactly this system's shape: REST/gRPC give the inventory and payment edges, the Kafka hop gives shipping and notification (because §7 set the producer/consumer span kinds), and asyncpg gives the Postgres edge.</a:t>
+            </a:r>
+            <a:endParaRPr lang="en-US" sz="1500" dirty="0"/>
+          </a:p>
+          <a:p>
+            <a:pPr algn="l" marL="342900" indent="-342900">
+              <a:lnSpc>
+                <a:spcPct val="115000"/>
+              </a:lnSpc>
+              <a:spcAft>
+                <a:spcPts val="600"/>
+              </a:spcAft>
+              <a:buSzPct val="100000"/>
+              <a:buChar char="●"/>
+            </a:pPr>
+            <a:r>
+              <a:rPr lang="en-US" sz="1500" dirty="0">
+                <a:solidFill>
+                  <a:srgbClr val="242424"/>
+                </a:solidFill>
+                <a:latin typeface="Red Hat Text" pitchFamily="34" charset="0"/>
+                <a:ea typeface="Red Hat Text" pitchFamily="34" charset="-122"/>
+                <a:cs typeface="Red Hat Text" pitchFamily="34" charset="-120"/>
+              </a:rPr>
+              <a:t>So you get the Kiali-style live map — request rate, error rate, latency, animated — with no service mesh, no sidecars, and no Kubernetes. Enabling it is two bits of config: the generator's processors plus remote-write, and Grafana's service map pointing at the metrics store.</a:t>
+            </a:r>
+            <a:endParaRPr lang="en-US" sz="1500" dirty="0"/>
+          </a:p>
+        </p:txBody>
+      </p:sp>
+    </p:spTree>
+  </p:cSld>
+  <p:clrMapOvr>
+    <a:masterClrMapping/>
+  </p:clrMapOvr>
+</p:sld>
+</file>
+
+<file path=ppt/slides/slide41.xml><?xml version="1.0" encoding="utf-8"?>
+<p:sld xmlns:a="http://schemas.openxmlformats.org/drawingml/2006/main" xmlns:r="http://schemas.openxmlformats.org/officeDocument/2006/relationships" xmlns:p="http://schemas.openxmlformats.org/presentationml/2006/main">
+  <p:cSld name="Slide 41">
+    <p:spTree>
+      <p:nvGrpSpPr>
+        <p:cNvPr id="1" name=""/>
+        <p:cNvGrpSpPr/>
+        <p:nvPr/>
+      </p:nvGrpSpPr>
+      <p:grpSpPr>
+        <a:xfrm>
+          <a:off x="0" y="0"/>
+          <a:ext cx="0" cy="0"/>
+          <a:chOff x="0" y="0"/>
+          <a:chExt cx="0" cy="0"/>
+        </a:xfrm>
+      </p:grpSpPr>
+      <p:sp>
+        <p:nvSpPr>
+          <p:cNvPr id="2" name="Text 0"/>
+          <p:cNvSpPr/>
+          <p:nvPr/>
+        </p:nvSpPr>
+        <p:spPr>
+          <a:xfrm>
+            <a:off x="566928" y="6364224"/>
+            <a:ext cx="914400" cy="274320"/>
+          </a:xfrm>
+          <a:prstGeom prst="rect">
+            <a:avLst/>
+          </a:prstGeom>
+          <a:noFill/>
+          <a:ln/>
+        </p:spPr>
+        <p:txBody>
+          <a:bodyPr wrap="square" rtlCol="0" anchor="ctr"/>
+          <a:lstStyle/>
+          <a:p>
+            <a:pPr algn="l" indent="0" marL="0">
+              <a:buNone/>
+            </a:pPr>
+            <a:r>
+              <a:rPr lang="en-US" sz="1000" dirty="0">
+                <a:solidFill>
+                  <a:srgbClr val="8A8A8A"/>
+                </a:solidFill>
+                <a:latin typeface="Red Hat Text" pitchFamily="34" charset="0"/>
+                <a:ea typeface="Red Hat Text" pitchFamily="34" charset="-122"/>
+                <a:cs typeface="Red Hat Text" pitchFamily="34" charset="-120"/>
+              </a:rPr>
+              <a:t>41</a:t>
+            </a:r>
+            <a:endParaRPr lang="en-US" sz="1000" dirty="0"/>
+          </a:p>
+        </p:txBody>
+      </p:sp>
+      <p:pic>
+        <p:nvPicPr>
+          <p:cNvPr id="3" name="Image 0" descr="./assets/logo-candidate-2.png">    </p:cNvPr>
+          <p:cNvPicPr>
+            <a:picLocks noChangeAspect="1"/>
+          </p:cNvPicPr>
+          <p:nvPr/>
+        </p:nvPicPr>
+        <p:blipFill>
+          <a:blip r:embed="rId1"/>
+          <a:stretch>
+            <a:fillRect/>
+          </a:stretch>
+        </p:blipFill>
+        <p:spPr>
+          <a:xfrm>
+            <a:off x="10561320" y="6355080"/>
+            <a:ext cx="1033272" cy="246888"/>
+          </a:xfrm>
+          <a:prstGeom prst="rect">
+            <a:avLst/>
+          </a:prstGeom>
+        </p:spPr>
+      </p:pic>
+      <p:sp>
+        <p:nvSpPr>
+          <p:cNvPr id="4" name="Text 1"/>
+          <p:cNvSpPr/>
+          <p:nvPr/>
+        </p:nvSpPr>
+        <p:spPr>
+          <a:xfrm>
+            <a:off x="566928" y="384048"/>
+            <a:ext cx="11055096" cy="292608"/>
+          </a:xfrm>
+          <a:prstGeom prst="rect">
+            <a:avLst/>
+          </a:prstGeom>
+          <a:noFill/>
+          <a:ln/>
+        </p:spPr>
+        <p:txBody>
+          <a:bodyPr wrap="square" rtlCol="0" anchor="ctr"/>
+          <a:lstStyle/>
+          <a:p>
+            <a:pPr algn="l" indent="0" marL="0">
+              <a:buNone/>
+            </a:pPr>
+            <a:r>
+              <a:rPr lang="en-US" sz="1200" b="1" spc="400" kern="0" dirty="0">
+                <a:solidFill>
+                  <a:srgbClr val="EE0000"/>
+                </a:solidFill>
+                <a:latin typeface="Overpass" pitchFamily="34" charset="0"/>
+                <a:ea typeface="Overpass" pitchFamily="34" charset="-122"/>
+                <a:cs typeface="Overpass" pitchFamily="34" charset="-120"/>
+              </a:rPr>
+              <a:t>WRAP-UP</a:t>
+            </a:r>
+            <a:endParaRPr lang="en-US" sz="1200" dirty="0"/>
+          </a:p>
+        </p:txBody>
+      </p:sp>
+      <p:sp>
+        <p:nvSpPr>
+          <p:cNvPr id="5" name="Text 2"/>
+          <p:cNvSpPr/>
+          <p:nvPr/>
+        </p:nvSpPr>
+        <p:spPr>
+          <a:xfrm>
+            <a:off x="566928" y="676656"/>
+            <a:ext cx="11055096" cy="1005840"/>
+          </a:xfrm>
+          <a:prstGeom prst="rect">
+            <a:avLst/>
+          </a:prstGeom>
+          <a:noFill/>
+          <a:ln/>
+        </p:spPr>
+        <p:txBody>
+          <a:bodyPr wrap="square" rtlCol="0" anchor="t"/>
+          <a:lstStyle/>
+          <a:p>
+            <a:pPr algn="l" indent="0" marL="0">
+              <a:buNone/>
+            </a:pPr>
+            <a:r>
+              <a:rPr lang="en-US" sz="3000" b="1" dirty="0">
+                <a:solidFill>
+                  <a:srgbClr val="151515"/>
+                </a:solidFill>
+                <a:latin typeface="Overpass" pitchFamily="34" charset="0"/>
+                <a:ea typeface="Overpass" pitchFamily="34" charset="-122"/>
+                <a:cs typeface="Overpass" pitchFamily="34" charset="-120"/>
+              </a:rPr>
+              <a:t>One request, four signals, end to end</a:t>
+            </a:r>
+            <a:endParaRPr lang="en-US" sz="3000" dirty="0"/>
+          </a:p>
+        </p:txBody>
+      </p:sp>
+      <p:sp>
+        <p:nvSpPr>
+          <p:cNvPr id="6" name="Text 3"/>
+          <p:cNvSpPr/>
+          <p:nvPr/>
+        </p:nvSpPr>
+        <p:spPr>
+          <a:xfrm>
+            <a:off x="566928" y="1691640"/>
+            <a:ext cx="11055096" cy="4434840"/>
+          </a:xfrm>
+          <a:prstGeom prst="rect">
+            <a:avLst/>
+          </a:prstGeom>
+          <a:noFill/>
+          <a:ln/>
+        </p:spPr>
+        <p:txBody>
+          <a:bodyPr wrap="square" rtlCol="0" anchor="t"/>
+          <a:lstStyle/>
+          <a:p>
+            <a:pPr algn="l" marL="342900" indent="-342900">
+              <a:lnSpc>
+                <a:spcPct val="115000"/>
+              </a:lnSpc>
+              <a:spcAft>
+                <a:spcPts val="600"/>
+              </a:spcAft>
+              <a:buSzPct val="100000"/>
+              <a:buChar char="●"/>
+            </a:pPr>
+            <a:r>
+              <a:rPr lang="en-US" sz="1500" dirty="0">
+                <a:solidFill>
+                  <a:srgbClr val="242424"/>
+                </a:solidFill>
+                <a:latin typeface="Red Hat Text" pitchFamily="34" charset="0"/>
+                <a:ea typeface="Red Hat Text" pitchFamily="34" charset="-122"/>
+                <a:cs typeface="Red Hat Text" pitchFamily="34" charset="-120"/>
+              </a:rPr>
+              <a:t>The full correlation story across the services: traces across REST and gRPC for free, metrics with exemplars, logs stamped with the trace_id, custom spans that carry the trace across Kafka, the honest auto/custom/hybrid trade-off, and a Grafana walkthrough that pivots trace → logs → metrics on one click.</a:t>
+            </a:r>
+            <a:endParaRPr lang="en-US" sz="1500" dirty="0"/>
+          </a:p>
+          <a:p>
+            <a:pPr algn="l" marL="342900" indent="-342900">
+              <a:lnSpc>
+                <a:spcPct val="115000"/>
+              </a:lnSpc>
+              <a:spcAft>
+                <a:spcPts val="600"/>
+              </a:spcAft>
+              <a:buSzPct val="100000"/>
+              <a:buChar char="●"/>
+            </a:pPr>
+            <a:r>
+              <a:rPr lang="en-US" sz="1500" dirty="0">
+                <a:solidFill>
+                  <a:srgbClr val="242424"/>
+                </a:solidFill>
+                <a:latin typeface="Red Hat Text" pitchFamily="34" charset="0"/>
+                <a:ea typeface="Red Hat Text" pitchFamily="34" charset="-122"/>
+                <a:cs typeface="Red Hat Text" pitchFamily="34" charset="-120"/>
+              </a:rPr>
+              <a:t>The pipeline part moved the costly decisions into the Collector: tail sampling that keeps errors, slow, and critical routes at volume while the app stays out of the sampling business, continuous profiling as the fourth signal, and a live service graph built from the traces — the whole system, at a glance.</a:t>
+            </a:r>
+            <a:endParaRPr lang="en-US" sz="1500" dirty="0"/>
+          </a:p>
+          <a:p>
+            <a:pPr algn="l" marL="342900" indent="-342900">
+              <a:lnSpc>
+                <a:spcPct val="115000"/>
+              </a:lnSpc>
+              <a:spcAft>
+                <a:spcPts val="600"/>
+              </a:spcAft>
+              <a:buSzPct val="100000"/>
+              <a:buChar char="●"/>
+            </a:pPr>
+            <a:r>
+              <a:rPr lang="en-US" sz="1500" dirty="0">
+                <a:solidFill>
+                  <a:srgbClr val="242424"/>
+                </a:solidFill>
+                <a:latin typeface="Red Hat Text" pitchFamily="34" charset="0"/>
+                <a:ea typeface="Red Hat Text" pitchFamily="34" charset="-122"/>
+                <a:cs typeface="Red Hat Text" pitchFamily="34" charset="-120"/>
+              </a:rPr>
+              <a:t>The tutorial mirrors these slides chapter for chapter (§0–§11), with six example services, the shared protos and obs library, and a runnable demo per chapter. It is authored against the target versions but not yet run end to end — it ships marked unverified, and a live rehearsal against the real stack is the next milestone.</a:t>
+            </a:r>
+            <a:endParaRPr lang="en-US" sz="1500" dirty="0"/>
           </a:p>
         </p:txBody>
       </p:sp>

</xml_diff>